<commit_message>
0.20.0: Anonymisierung, Absage durch Anbietende, Archiv, Statistik und Handbücher angepasst
Co-Authored-By: Claude Sonnet 5.5 <noreply@anthropic.com>
Claude-Session: https://claude.ai/code/session_01Rb6Lxu6RnQK1jTbYRZcruJ
</commit_message>
<xml_diff>
--- a/docs/LearnTogether-AD_Praesentation.pptx
+++ b/docs/LearnTogether-AD_Praesentation.pptx
@@ -972,7 +972,7 @@
           <a:p>
             <a:r>
               <a:rPr lang="en-US" dirty="0"/>
-              <a:t>Das Formular führt in fünf Abschnitten: wer, worum, wann, was und Teams-Link. Die Plattform prüft Zeitfenster und Dauer. Nach dem Speichern erhält die anbietende Person einen Veranstaltungscode.</a:t>
+              <a:t>Das Formular führt in fünf Abschnitten: wer, worum, wann, was und Teams-Link. Die Plattform prüft Zeitfenster und Dauer. Nach dem Speichern erhält die anbietende Person einen Veranstaltungscode. Mit ihm kann sie die Veranstaltung auch absagen. Angemeldete Personen sehen die Absage unter Meine Anmeldung, die Plattform verschickt keine E-Mails.</a:t>
             </a:r>
             <a:endParaRPr lang="en-US" dirty="0"/>
           </a:p>
@@ -1588,7 +1588,7 @@
           <a:p>
             <a:r>
               <a:rPr lang="en-US" dirty="0"/>
-              <a:t>Bei privaten Sessions werden Name und E-Mail-Adresse der Anbietenden und Teilnehmenden im Admin-Bereich nach der Veranstaltung anonymisiert. Es bleiben nur Zahlen für die Statistik. Bei dienstlichen Sessions müssen die Daten für die spätere IDD-Anrechnung gespeichert bleiben. Sie dienen ausschließlich dem Nachweis und der Anrechnung. Zugriff haben nur die Administratoren in VH-VP-TV. Die Daten werden nicht veröffentlicht. Die automatische Anonymisierung ist ein Konzept und wird technisch umgesetzt, die Aufbewahrungsfrist stimmen wir mit Datenschutz und Betriebsrat ab.</a:t>
+              <a:t>Die Anonymisierung ist in der Plattform umgesetzt und läuft automatisch. Bei privaten Sessions werden Name und E-Mail-Adresse der Anbietenden und Teilnehmenden am Tag nach der Veranstaltung anonymisiert. Es bleiben nur Zahlen für die Statistik. Bei dienstlichen Sessions bleiben die Daten fünf Jahre gespeichert, ausschließlich für Nachweis und Anrechnung, danach werden sie ebenfalls anonymisiert. Abgesagte Veranstaltungen werden am Tag nach dem geplanten Termin anonymisiert. Zugriff haben nur die Administratoren in VH-VP-TV. Die Daten werden nicht veröffentlicht. Die Fristen und Zwecke stimmen wir mit Datenschutz und Betriebsrat ab.</a:t>
             </a:r>
             <a:endParaRPr lang="en-US" dirty="0"/>
           </a:p>
@@ -4605,7 +4605,7 @@
                 <a:ea typeface="Arial" pitchFamily="34" charset="-122"/>
                 <a:cs typeface="Arial" pitchFamily="34" charset="-120"/>
               </a:rPr>
-              <a:t>Veranstaltungscode</a:t>
+              <a:t>Veranstaltungscode und Absage</a:t>
             </a:r>
             <a:endParaRPr lang="en-US" sz="1800" dirty="0"/>
           </a:p>
@@ -4644,7 +4644,7 @@
                 <a:ea typeface="Arial" pitchFamily="34" charset="-122"/>
                 <a:cs typeface="Arial" pitchFamily="34" charset="-120"/>
               </a:rPr>
-              <a:t>Er zeigt später die Teilnehmerliste mit den Namen.</a:t>
+              <a:t>Er zeigt die Teilnehmerliste mit Namen. Damit lässt sich die Veranstaltung auch absagen, selbst mit Anmeldungen.</a:t>
             </a:r>
             <a:endParaRPr lang="en-US" sz="1400" dirty="0"/>
           </a:p>
@@ -10176,7 +10176,7 @@
                 <a:ea typeface="Arial" pitchFamily="34" charset="-122"/>
                 <a:cs typeface="Arial" pitchFamily="34" charset="-120"/>
               </a:rPr>
-              <a:t>Private Sessions werden anonymisiert, dienstliche nur für den Nachweis gespeichert</a:t>
+              <a:t>Private Sessions werden am Tag danach anonymisiert, dienstliche nach fünf Jahren</a:t>
             </a:r>
             <a:endParaRPr lang="en-US" sz="2000" dirty="0"/>
           </a:p>
@@ -10426,7 +10426,7 @@
                 <a:ea typeface="Arial" pitchFamily="34" charset="-122"/>
                 <a:cs typeface="Arial" pitchFamily="34" charset="-120"/>
               </a:rPr>
-              <a:t>Name und E-Mail werden nach der Veranstaltung anonymisiert.</a:t>
+              <a:t>Name und E-Mail werden am Tag nach der Veranstaltung automatisch anonymisiert.</a:t>
             </a:r>
             <a:endParaRPr lang="en-US" sz="1400" dirty="0"/>
           </a:p>
@@ -10447,7 +10447,7 @@
                 <a:ea typeface="Arial" pitchFamily="34" charset="-122"/>
                 <a:cs typeface="Arial" pitchFamily="34" charset="-120"/>
               </a:rPr>
-              <a:t>Im Admin-Bereich bleiben nur Zahlen für die Statistik.</a:t>
+              <a:t>Im Admin-Bereich und im Archiv bleiben nur Zahlen für die Statistik.</a:t>
             </a:r>
             <a:endParaRPr lang="en-US" sz="1400" dirty="0"/>
           </a:p>
@@ -10599,7 +10599,7 @@
                 <a:ea typeface="Arial" pitchFamily="34" charset="-122"/>
                 <a:cs typeface="Arial" pitchFamily="34" charset="-120"/>
               </a:rPr>
-              <a:t>Daten der Anbietenden und Teilnehmenden bleiben gespeichert.</a:t>
+              <a:t>Daten der Anbietenden und Teilnehmenden bleiben fünf Jahre gespeichert.</a:t>
             </a:r>
             <a:endParaRPr lang="en-US" sz="1400" dirty="0"/>
           </a:p>
@@ -10641,7 +10641,7 @@
                 <a:ea typeface="Arial" pitchFamily="34" charset="-122"/>
                 <a:cs typeface="Arial" pitchFamily="34" charset="-120"/>
               </a:rPr>
-              <a:t>Aufbewahrung nach den IDD-Vorgaben, Frist mit Datenschutz abgestimmt.</a:t>
+              <a:t>Danach werden sie automatisch anonymisiert.</a:t>
             </a:r>
             <a:endParaRPr lang="en-US" sz="1400" dirty="0"/>
           </a:p>
@@ -12383,7 +12383,7 @@
                 <a:ea typeface="Arial" pitchFamily="34" charset="-122"/>
                 <a:cs typeface="Arial" pitchFamily="34" charset="-120"/>
               </a:rPr>
-              <a:t>Termine selbst anbieten</a:t>
+              <a:t>Termine anbieten und absagen</a:t>
             </a:r>
             <a:endParaRPr lang="en-US" sz="1250" dirty="0"/>
           </a:p>
@@ -12509,7 +12509,7 @@
                 <a:ea typeface="Arial" pitchFamily="34" charset="-122"/>
                 <a:cs typeface="Arial" pitchFamily="34" charset="-120"/>
               </a:rPr>
-              <a:t>Statistik für die Administration</a:t>
+              <a:t>Archiv, Statistik und automatische Anonymisierung</a:t>
             </a:r>
             <a:endParaRPr lang="en-US" sz="1250" dirty="0"/>
           </a:p>
@@ -12724,7 +12724,7 @@
                 <a:ea typeface="Arial" pitchFamily="34" charset="-122"/>
                 <a:cs typeface="Arial" pitchFamily="34" charset="-120"/>
               </a:rPr>
-              <a:t>Anonymisierung privater Daten</a:t>
+              <a:t>Technischer Nachweis für dienstliche Sessions</a:t>
             </a:r>
             <a:endParaRPr lang="en-US" sz="1250" dirty="0"/>
           </a:p>
@@ -12787,7 +12787,7 @@
                 <a:ea typeface="Arial" pitchFamily="34" charset="-122"/>
                 <a:cs typeface="Arial" pitchFamily="34" charset="-120"/>
               </a:rPr>
-              <a:t>Nachweis für dienstliche Sessions</a:t>
+              <a:t>Abstimmung mit Datenschutz und Betriebsrat</a:t>
             </a:r>
             <a:endParaRPr lang="en-US" sz="1250" dirty="0"/>
           </a:p>
@@ -13611,7 +13611,7 @@
                           <a:ea typeface="Arial" pitchFamily="34" charset="-122"/>
                           <a:cs typeface="Arial" pitchFamily="34" charset="-120"/>
                         </a:rPr>
-                        <a:t>Datensparsame Plattform, Anonymisierung privater Sessions, Zugriff nur für VH-VP-TV, Einbindung des Betriebsrats.</a:t>
+                        <a:t>Datensparsame Plattform, automatische Anonymisierung, Zugriff nur für VH-VP-TV, Einbindung des Betriebsrats.</a:t>
                       </a:r>
                       <a:endParaRPr lang="en-US" sz="1300" dirty="0">
                         <a:latin typeface="Arial" charset="0"/>
@@ -14343,7 +14343,7 @@
                 <a:ea typeface="Arial" pitchFamily="34" charset="-122"/>
                 <a:cs typeface="Arial" pitchFamily="34" charset="-120"/>
               </a:rPr>
-              <a:t>Anonymisierung technisch umsetzen</a:t>
+              <a:t>Datenkonzept mit Datenschutz abstimmen</a:t>
             </a:r>
             <a:endParaRPr lang="en-US" sz="1500" dirty="0"/>
           </a:p>

</xml_diff>

<commit_message>
Präsentation an Konten, Bewertungen und Anonymisierung nach fünf Jahren angepasst
Co-Authored-By: Claude Sonnet 5.5 <noreply@anthropic.com>
Claude-Session: https://claude.ai/code/session_01Rb6Lxu6RnQK1jTbYRZcruJ
</commit_message>
<xml_diff>
--- a/docs/LearnTogether-AD_Praesentation.pptx
+++ b/docs/LearnTogether-AD_Praesentation.pptx
@@ -884,7 +884,7 @@
           <a:p>
             <a:r>
               <a:rPr lang="en-US" dirty="0"/>
-              <a:t>Der Katalog zeigt alle künftigen Termine in Reihen nach Thema. Der Schalter wechselt zwischen dienstlich und privat. Nach der Anmeldung erscheinen Teams-Link, Kalenderdatei und Buchungscode. Der Buchungscode ist der Schlüssel, um die Anmeldung wieder aufzurufen oder zu stornieren. Es wird keine E-Mail verschickt.</a:t>
+              <a:t>Der Katalog zeigt alle künftigen Termine in Reihen nach Thema. Der Schalter wechselt zwischen dienstlich und privat. Nach der Anmeldung erscheinen Teams-Link und Kalenderdatei, später auch unter Meine Anmeldungen. Dort lässt sich die Anmeldung auch zurückgeben. Nach dem Termin vergeben Teilnehmende ein bis fünf Sterne.</a:t>
             </a:r>
             <a:endParaRPr lang="en-US" dirty="0"/>
           </a:p>
@@ -972,7 +972,7 @@
           <a:p>
             <a:r>
               <a:rPr lang="en-US" dirty="0"/>
-              <a:t>Das Formular führt in fünf Abschnitten: wer, worum, wann, was und Teams-Link. Die Plattform prüft Zeitfenster und Dauer. Nach dem Speichern erhält die anbietende Person einen Veranstaltungscode. Mit ihm kann sie die Veranstaltung auch absagen. Angemeldete Personen sehen die Absage unter Meine Anmeldung, die Plattform verschickt keine E-Mails.</a:t>
+              <a:t>Das Formular führt in vier Abschnitten: worum, wann, was und Teams-Link. Die Plattform prüft Zeitfenster und Dauer. Als Anbieter erscheint der Benutzername. Unter Meine Veranstaltungen lässt sich die Veranstaltung auch absagen. Angemeldete Personen sehen die Absage als Mitteilung, die Plattform verschickt keine E-Mails.</a:t>
             </a:r>
             <a:endParaRPr lang="en-US" dirty="0"/>
           </a:p>
@@ -1588,7 +1588,7 @@
           <a:p>
             <a:r>
               <a:rPr lang="en-US" dirty="0"/>
-              <a:t>Die Anonymisierung ist in der Plattform umgesetzt und läuft automatisch. Bei privaten Sessions werden Name und E-Mail-Adresse der Anbietenden und Teilnehmenden am Tag nach der Veranstaltung anonymisiert. Es bleiben nur Zahlen für die Statistik. Bei dienstlichen Sessions bleiben die Daten fünf Jahre gespeichert, ausschließlich für Nachweis und Anrechnung, danach werden sie ebenfalls anonymisiert. Abgesagte Veranstaltungen werden am Tag nach dem geplanten Termin anonymisiert. Zugriff haben nur die Administratoren in VH-VP-TV. Die Daten werden nicht veröffentlicht. Die Fristen und Zwecke stimmen wir mit Datenschutz und Betriebsrat ab.</a:t>
+              <a:t>Die Anonymisierung ist in der Plattform umgesetzt und läuft automatisch. Öffentlich sichtbar ist nur der Benutzername. Echter Name, XV-Nummer und E-Mail-Adresse sehen nur die betroffene Person und die Administration. Die Daten jeder Veranstaltung bleiben fünf Jahre nach dem Ende gespeichert, ausschließlich für Nachweis und Anrechnung. Das gilt für private und dienstliche Sessions gleichermaßen. Danach werden sie anonymisiert, nur Zähler bleiben. Zugriff haben nur die Administratoren in VH-VP-TV. Die Daten werden nicht veröffentlicht. Die Fristen und Zwecke stimmen wir mit Datenschutz und Betriebsrat ab.</a:t>
             </a:r>
             <a:endParaRPr lang="en-US" dirty="0"/>
           </a:p>
@@ -2996,7 +2996,7 @@
           <a:p>
             <a:r>
               <a:rPr lang="en-US" dirty="0"/>
-              <a:t>Der Ablauf ist bewusst einfach. Wer sich anmeldet, erhält einen Buchungscode und eine Kalenderdatei mit dem Teams-Link. Wer anbietet, erhält einen Veranstaltungscode für die Teilnehmerliste. Es werden keine E-Mails verschickt.</a:t>
+              <a:t>Der Ablauf ist bewusst einfach. Alle registrieren sich einmal mit einem frei gewählten Benutzernamen. Teams-Link, Kalenderdatei, Abmeldung und Bewertung finden sie unter Meine Anmeldungen. Es werden keine E-Mails verschickt.</a:t>
             </a:r>
             <a:endParaRPr lang="en-US" dirty="0"/>
           </a:p>
@@ -3717,7 +3717,7 @@
                 <a:ea typeface="Arial" pitchFamily="34" charset="-122"/>
                 <a:cs typeface="Arial" pitchFamily="34" charset="-120"/>
               </a:rPr>
-              <a:t>Zwei Klicks bis zum Platz, ganz ohne Benutzerkonto</a:t>
+              <a:t>Zwei Klicks bis zum Platz</a:t>
             </a:r>
             <a:endParaRPr lang="en-US" sz="2000" dirty="0"/>
           </a:p>
@@ -3868,7 +3868,7 @@
       </p:pic>
       <p:pic>
         <p:nvPicPr>
-          <p:cNvPr id="9" name="Image 2" descr="/home/user/ruv_learntogether/src/handbuch/shots/angemeldet.jpg">    </p:cNvPr>
+          <p:cNvPr id="9" name="Image 2" descr="/home/user/ruv_learntogether/src/handbuch/shots/buchung.jpg">    </p:cNvPr>
           <p:cNvPicPr>
             <a:picLocks noChangeAspect="1"/>
           </p:cNvPicPr>
@@ -3883,7 +3883,7 @@
         <p:spPr>
           <a:xfrm>
             <a:off x="6199632" y="1463040"/>
-            <a:ext cx="5486400" cy="2551001"/>
+            <a:ext cx="5486400" cy="2481111"/>
           </a:xfrm>
           <a:prstGeom prst="rect">
             <a:avLst/>
@@ -4040,7 +4040,7 @@
                 <a:ea typeface="Arial" pitchFamily="34" charset="-122"/>
                 <a:cs typeface="Arial" pitchFamily="34" charset="-120"/>
               </a:rPr>
-              <a:t>Name und E-Mail genügen. Danach erscheinen Teams-Link, Kalenderdatei und Buchungscode. Die Plattform verschickt keine E-Mails.</a:t>
+              <a:t>Ein Klick genügt. Danach erscheinen Teams-Link und Kalenderdatei. Die Plattform verschickt keine E-Mails.</a:t>
             </a:r>
             <a:endParaRPr lang="en-US" sz="1400" dirty="0"/>
           </a:p>
@@ -4371,7 +4371,7 @@
                 <a:ea typeface="Arial" pitchFamily="34" charset="-122"/>
                 <a:cs typeface="Arial" pitchFamily="34" charset="-120"/>
               </a:rPr>
-              <a:t>Wer, worum, wann</a:t>
+              <a:t>Worum, wann</a:t>
             </a:r>
             <a:endParaRPr lang="en-US" sz="1800" dirty="0"/>
           </a:p>
@@ -4410,7 +4410,7 @@
                 <a:ea typeface="Arial" pitchFamily="34" charset="-122"/>
                 <a:cs typeface="Arial" pitchFamily="34" charset="-120"/>
               </a:rPr>
-              <a:t>Name, Titel, Thema und ein Termin im erlaubten Zeitfenster.</a:t>
+              <a:t>Titel, Thema und ein Termin im erlaubten Zeitfenster.</a:t>
             </a:r>
             <a:endParaRPr lang="en-US" sz="1400" dirty="0"/>
           </a:p>
@@ -4605,7 +4605,7 @@
                 <a:ea typeface="Arial" pitchFamily="34" charset="-122"/>
                 <a:cs typeface="Arial" pitchFamily="34" charset="-120"/>
               </a:rPr>
-              <a:t>Veranstaltungscode und Absage</a:t>
+              <a:t>Meine Veranstaltungen</a:t>
             </a:r>
             <a:endParaRPr lang="en-US" sz="1800" dirty="0"/>
           </a:p>
@@ -4644,7 +4644,7 @@
                 <a:ea typeface="Arial" pitchFamily="34" charset="-122"/>
                 <a:cs typeface="Arial" pitchFamily="34" charset="-120"/>
               </a:rPr>
-              <a:t>Er zeigt die Teilnehmerliste mit Namen. Damit lässt sich die Veranstaltung auch absagen, selbst mit Anmeldungen.</a:t>
+              <a:t>Teilnehmende mit Benutzernamen, Bewertung und Absage, selbst mit Anmeldungen.</a:t>
             </a:r>
             <a:endParaRPr lang="en-US" sz="1400" dirty="0"/>
           </a:p>
@@ -7592,7 +7592,7 @@
                 <a:ea typeface="Arial" pitchFamily="34" charset="-122"/>
                 <a:cs typeface="Arial" pitchFamily="34" charset="-120"/>
               </a:rPr>
-              <a:t>Teilnehmerliste mit Veranstaltungscode</a:t>
+              <a:t>Teilnehmende, Bewertung, Abzeichen und Expertenstatus</a:t>
             </a:r>
             <a:endParaRPr lang="en-US" sz="1400" dirty="0"/>
           </a:p>
@@ -10176,7 +10176,7 @@
                 <a:ea typeface="Arial" pitchFamily="34" charset="-122"/>
                 <a:cs typeface="Arial" pitchFamily="34" charset="-120"/>
               </a:rPr>
-              <a:t>Private Sessions werden am Tag danach anonymisiert, dienstliche nach fünf Jahren</a:t>
+              <a:t>Öffentlich nur der Benutzername, Anonymisierung nach fünf Jahren</a:t>
             </a:r>
             <a:endParaRPr lang="en-US" sz="2000" dirty="0"/>
           </a:p>
@@ -10383,7 +10383,7 @@
                 <a:ea typeface="Arial" pitchFamily="34" charset="-122"/>
                 <a:cs typeface="Arial" pitchFamily="34" charset="-120"/>
               </a:rPr>
-              <a:t>Private Sessions</a:t>
+              <a:t>Was andere sehen</a:t>
             </a:r>
             <a:endParaRPr lang="en-US" sz="2000" dirty="0"/>
           </a:p>
@@ -10426,7 +10426,7 @@
                 <a:ea typeface="Arial" pitchFamily="34" charset="-122"/>
                 <a:cs typeface="Arial" pitchFamily="34" charset="-120"/>
               </a:rPr>
-              <a:t>Name und E-Mail werden am Tag nach der Veranstaltung automatisch anonymisiert.</a:t>
+              <a:t>Nur den frei gewählten Benutzernamen mit Abzeichen.</a:t>
             </a:r>
             <a:endParaRPr lang="en-US" sz="1400" dirty="0"/>
           </a:p>
@@ -10447,7 +10447,7 @@
                 <a:ea typeface="Arial" pitchFamily="34" charset="-122"/>
                 <a:cs typeface="Arial" pitchFamily="34" charset="-120"/>
               </a:rPr>
-              <a:t>Im Admin-Bereich und im Archiv bleiben nur Zahlen für die Statistik.</a:t>
+              <a:t>Anbietende sehen Teilnehmende nur mit Benutzernamen.</a:t>
             </a:r>
             <a:endParaRPr lang="en-US" sz="1400" dirty="0"/>
           </a:p>
@@ -10468,7 +10468,7 @@
                 <a:ea typeface="Arial" pitchFamily="34" charset="-122"/>
                 <a:cs typeface="Arial" pitchFamily="34" charset="-120"/>
               </a:rPr>
-              <a:t>Niemand kann später nachvollziehen, wer teilgenommen hat.</a:t>
+              <a:t>Bewertungen sehen Anbietende nur als Durchschnitt.</a:t>
             </a:r>
             <a:endParaRPr lang="en-US" sz="1400" dirty="0"/>
           </a:p>
@@ -10556,7 +10556,7 @@
                 <a:ea typeface="Arial" pitchFamily="34" charset="-122"/>
                 <a:cs typeface="Arial" pitchFamily="34" charset="-120"/>
               </a:rPr>
-              <a:t>Dienstliche Sessions</a:t>
+              <a:t>Aufbewahrung und Anonymisierung</a:t>
             </a:r>
             <a:endParaRPr lang="en-US" sz="2000" dirty="0"/>
           </a:p>
@@ -10599,7 +10599,7 @@
                 <a:ea typeface="Arial" pitchFamily="34" charset="-122"/>
                 <a:cs typeface="Arial" pitchFamily="34" charset="-120"/>
               </a:rPr>
-              <a:t>Daten der Anbietenden und Teilnehmenden bleiben fünf Jahre gespeichert.</a:t>
+              <a:t>Daten bleiben fünf Jahre nach dem Ende gespeichert.</a:t>
             </a:r>
             <a:endParaRPr lang="en-US" sz="1400" dirty="0"/>
           </a:p>
@@ -10944,7 +10944,7 @@
                 <a:ea typeface="Arial" pitchFamily="34" charset="-122"/>
                 <a:cs typeface="Arial" pitchFamily="34" charset="-120"/>
               </a:rPr>
-              <a:t>Kein Benutzerkonto, kein E-Mail-Versand</a:t>
+              <a:t>Kein E-Mail-Versand</a:t>
             </a:r>
             <a:endParaRPr lang="en-US" sz="1300" dirty="0"/>
           </a:p>
@@ -12320,7 +12320,7 @@
                 <a:ea typeface="Arial" pitchFamily="34" charset="-122"/>
                 <a:cs typeface="Arial" pitchFamily="34" charset="-120"/>
               </a:rPr>
-              <a:t>Anmelden ohne Benutzerkonto</a:t>
+              <a:t>Registrierung und Anmeldung mit Benutzername</a:t>
             </a:r>
             <a:endParaRPr lang="en-US" sz="1250" dirty="0"/>
           </a:p>
@@ -12509,7 +12509,7 @@
                 <a:ea typeface="Arial" pitchFamily="34" charset="-122"/>
                 <a:cs typeface="Arial" pitchFamily="34" charset="-120"/>
               </a:rPr>
-              <a:t>Archiv, Statistik und automatische Anonymisierung</a:t>
+              <a:t>Bewertung, Abzeichen, Archiv, Statistik</a:t>
             </a:r>
             <a:endParaRPr lang="en-US" sz="1250" dirty="0"/>
           </a:p>
@@ -22359,7 +22359,7 @@
                 <a:ea typeface="Arial" pitchFamily="34" charset="-122"/>
                 <a:cs typeface="Arial" pitchFamily="34" charset="-120"/>
               </a:rPr>
-              <a:t>Teilnahme und Angebot sind freiwillig. Es gibt keine Bewertung einzelner Personen.</a:t>
+              <a:t>Teilnahme und Angebot sind freiwillig. Öffentlich erscheint nur der Benutzername.</a:t>
             </a:r>
             <a:endParaRPr lang="en-US" sz="1400" dirty="0"/>
           </a:p>
@@ -22526,7 +22526,7 @@
                 <a:ea typeface="Arial" pitchFamily="34" charset="-122"/>
                 <a:cs typeface="Arial" pitchFamily="34" charset="-120"/>
               </a:rPr>
-              <a:t>Kein Benutzerkonto, Anmeldung in zwei Klicks, Angebot in wenigen Minuten angelegt.</a:t>
+              <a:t>Einmal registrieren, dann Anmeldung in zwei Klicks und Angebot in wenigen Minuten angelegt.</a:t>
             </a:r>
             <a:endParaRPr lang="en-US" sz="1400" dirty="0"/>
           </a:p>
@@ -23811,7 +23811,7 @@
                 <a:ea typeface="Arial" pitchFamily="34" charset="-122"/>
                 <a:cs typeface="Arial" pitchFamily="34" charset="-120"/>
               </a:rPr>
-              <a:t>Vier Schritte, ganz ohne Benutzerkonto</a:t>
+              <a:t>Vier Schritte mit eigenem Konto</a:t>
             </a:r>
             <a:endParaRPr lang="en-US" sz="2000" dirty="0"/>
           </a:p>
@@ -24286,7 +24286,7 @@
                 <a:ea typeface="Arial" pitchFamily="34" charset="-122"/>
                 <a:cs typeface="Arial" pitchFamily="34" charset="-120"/>
               </a:rPr>
-              <a:t>Name und E-Mail eingeben. Der Platz ist sofort reserviert.</a:t>
+              <a:t>Mit dem Konto anmelden. Der Platz ist sofort reserviert.</a:t>
             </a:r>
             <a:endParaRPr lang="en-US" sz="1400" dirty="0"/>
           </a:p>
@@ -24476,7 +24476,7 @@
                 <a:ea typeface="Arial" pitchFamily="34" charset="-122"/>
                 <a:cs typeface="Arial" pitchFamily="34" charset="-120"/>
               </a:rPr>
-              <a:t>Buchungscode merken, Termin in den Kalender übernehmen, über den Teams-Link beitreten.</a:t>
+              <a:t>Termin in den Kalender übernehmen, über den Teams-Link beitreten und danach bewerten.</a:t>
             </a:r>
             <a:endParaRPr lang="en-US" sz="1400" dirty="0"/>
           </a:p>
@@ -24666,7 +24666,7 @@
                 <a:ea typeface="Arial" pitchFamily="34" charset="-122"/>
                 <a:cs typeface="Arial" pitchFamily="34" charset="-120"/>
               </a:rPr>
-              <a:t>Selbst einen Termin anlegen. Der Veranstaltungscode zeigt später die Teilnehmerliste.</a:t>
+              <a:t>Selbst einen Termin anlegen. Unter Meine Veranstaltungen siehst du Teilnehmende und Bewertungen.</a:t>
             </a:r>
             <a:endParaRPr lang="en-US" sz="1400" dirty="0"/>
           </a:p>
@@ -24705,7 +24705,7 @@
                 <a:ea typeface="Arial" pitchFamily="34" charset="-122"/>
                 <a:cs typeface="Arial" pitchFamily="34" charset="-120"/>
               </a:rPr>
-              <a:t>Kein E-Mail-Versand: Teams-Link, Kalenderdatei und Buchungscode erscheinen direkt nach der Anmeldung.</a:t>
+              <a:t>Kein E-Mail-Versand: Teams-Link und Kalenderdatei erscheinen direkt nach der Anmeldung. Absagen erscheinen als Mitteilung.</a:t>
             </a:r>
             <a:endParaRPr lang="en-US" sz="1400" dirty="0"/>
           </a:p>

</xml_diff>

<commit_message>
0.22.0: Öffentliches Profil mit Freigaben, Bio und kommenden Veranstaltungen
Co-Authored-By: Claude Sonnet 5.5 <noreply@anthropic.com>
Claude-Session: https://claude.ai/code/session_01Rb6Lxu6RnQK1jTbYRZcruJ
</commit_message>
<xml_diff>
--- a/docs/LearnTogether-AD_Praesentation.pptx
+++ b/docs/LearnTogether-AD_Praesentation.pptx
@@ -10426,7 +10426,7 @@
                 <a:ea typeface="Arial" pitchFamily="34" charset="-122"/>
                 <a:cs typeface="Arial" pitchFamily="34" charset="-120"/>
               </a:rPr>
-              <a:t>Nur den frei gewählten Benutzernamen mit Abzeichen.</a:t>
+              <a:t>Standard: nur der frei gewählte Benutzername mit Abzeichen.</a:t>
             </a:r>
             <a:endParaRPr lang="en-US" sz="1400" dirty="0"/>
           </a:p>
@@ -10447,7 +10447,7 @@
                 <a:ea typeface="Arial" pitchFamily="34" charset="-122"/>
                 <a:cs typeface="Arial" pitchFamily="34" charset="-120"/>
               </a:rPr>
-              <a:t>Anbietende sehen Teilnehmende nur mit Benutzernamen.</a:t>
+              <a:t>Optional: öffentliches Profil mit Themen, Bio und einzelnen Freigaben.</a:t>
             </a:r>
             <a:endParaRPr lang="en-US" sz="1400" dirty="0"/>
           </a:p>
@@ -10468,7 +10468,7 @@
                 <a:ea typeface="Arial" pitchFamily="34" charset="-122"/>
                 <a:cs typeface="Arial" pitchFamily="34" charset="-120"/>
               </a:rPr>
-              <a:t>Bewertungen sehen Anbietende nur als Durchschnitt.</a:t>
+              <a:t>Anbietende sehen Teilnehmende nur mit Benutzernamen.</a:t>
             </a:r>
             <a:endParaRPr lang="en-US" sz="1400" dirty="0"/>
           </a:p>

</xml_diff>

<commit_message>
0.25.0: Profilbilder, eigene Fotos als Platzhalter, mehr Motive, Bilder in Listen, Statistik in Bereichen, Navigation
Co-Authored-By: Claude Opus 5.5 <noreply@anthropic.com>
Claude-Session: https://claude.ai/code/session_01Rb6Lxu6RnQK1jTbYRZcruJ
</commit_message>
<xml_diff>
--- a/docs/LearnTogether-AD_Praesentation.pptx
+++ b/docs/LearnTogether-AD_Praesentation.pptx
@@ -1063,7 +1063,7 @@
           <a:p>
             <a:r>
               <a:rPr lang="en-US" dirty="0"/>
-              <a:t>Wer kein eigenes Foto hat, wählt eines von 50 Platzhalterbildern. Die Motive folgen der R+V-Bildwelt: flache Markenfarben und Piktogramme aus dem R+V-Iconfont. Eine Suche hilft bei der Auswahl. Die Motive sind mit KI gestaltet und tragen deshalb das KI-Label der R+V.</a:t>
+              <a:t>Wer kein eigenes Foto hat, wählt eines von rund 70 Platzhalterbildern, dienstlich wie privat. Die Administration kann zusätzlich echte Fotos hinterlegen, etwa aus der R+V-Mediendatenbank. Die Motive folgen der R+V-Bildwelt: flache Markenfarben und Piktogramme aus dem R+V-Iconfont. Eine Suche hilft bei der Auswahl. Die Motive sind mit KI gestaltet und tragen deshalb das KI-Label der R+V.</a:t>
             </a:r>
             <a:endParaRPr lang="en-US" dirty="0"/>
           </a:p>
@@ -1679,7 +1679,7 @@
           <a:p>
             <a:r>
               <a:rPr lang="en-US" dirty="0"/>
-              <a:t>Im Admin-Bereich gibt es 8 Kennzahlen und 13 Auswertungen mit PDF-Export. Wir betrachten Termine pro Monat, Teilnehmende, Auslastung und Themen. Die Abbildung zeigt Beispieldaten. Die Auswertung bleibt aggregiert.</a:t>
+              <a:t>Im Admin-Bereich gibt es sechs Bereiche mit über 20 Kennzahlen und rund 20 Auswertungen, jeweils mit PDF-Export. Wir betrachten Angebot, Nachfrage, Nutzende, Bewertungen und Datenschutz. Die Abbildung zeigt Beispieldaten. Die Auswertung bleibt aggregiert.</a:t>
             </a:r>
             <a:endParaRPr lang="en-US" dirty="0"/>
           </a:p>
@@ -5320,7 +5320,7 @@
                 <a:ea typeface="Arial" pitchFamily="34" charset="-122"/>
                 <a:cs typeface="Arial" pitchFamily="34" charset="-120"/>
               </a:rPr>
-              <a:t>50 Platzhalterbilder</a:t>
+              <a:t>Rund 70 Motive und Fotos</a:t>
             </a:r>
             <a:endParaRPr lang="en-US" sz="1800" dirty="0"/>
           </a:p>
@@ -5359,7 +5359,7 @@
                 <a:ea typeface="Arial" pitchFamily="34" charset="-122"/>
                 <a:cs typeface="Arial" pitchFamily="34" charset="-120"/>
               </a:rPr>
-              <a:t>Vom Kundengespräch bis zum Garten, mit Suche nach Begriffen.</a:t>
+              <a:t>Vom Kundengespräch bis zum Spieleabend, dazu Fotos der Administration, mit Suche.</a:t>
             </a:r>
             <a:endParaRPr lang="en-US" sz="1400" dirty="0"/>
           </a:p>
@@ -6450,7 +6450,7 @@
                 <a:ea typeface="Arial" pitchFamily="34" charset="-122"/>
                 <a:cs typeface="Arial" pitchFamily="34" charset="-120"/>
               </a:rPr>
-              <a:t>Mein Profil in fünf Bereichen</a:t>
+              <a:t>Profil mit Profilbild</a:t>
             </a:r>
             <a:endParaRPr lang="en-US" sz="1800" dirty="0"/>
           </a:p>
@@ -6489,7 +6489,7 @@
                 <a:ea typeface="Arial" pitchFamily="34" charset="-122"/>
                 <a:cs typeface="Arial" pitchFamily="34" charset="-120"/>
               </a:rPr>
-              <a:t>Übersicht, Archiv der Veranstaltungen und Teilnahmen, Veröffentlichung, Konto.</a:t>
+              <a:t>Eigenes Foto oder Illustration, fünf Bereiche von Übersicht bis Konto.</a:t>
             </a:r>
             <a:endParaRPr lang="en-US" sz="1400" dirty="0"/>
           </a:p>
@@ -11139,7 +11139,7 @@
                 <a:ea typeface="Arial" pitchFamily="34" charset="-122"/>
                 <a:cs typeface="Arial" pitchFamily="34" charset="-120"/>
               </a:rPr>
-              <a:t>Wiederkehrende Anbietende, Vorlauf der Anmeldungen</a:t>
+              <a:t>Bewertungen, aktive Konten, Abzeichen und Expertenstatus</a:t>
             </a:r>
             <a:endParaRPr lang="en-US" sz="1400" dirty="0"/>
           </a:p>
@@ -11217,7 +11217,7 @@
                 <a:ea typeface="Arial" pitchFamily="34" charset="-122"/>
                 <a:cs typeface="Arial" pitchFamily="34" charset="-120"/>
               </a:rPr>
-              <a:t>Jede Auswertung und der Gesamtbericht als PDF</a:t>
+              <a:t>Jede Auswertung, jeder Bereich und der Gesamtbericht als PDF</a:t>
             </a:r>
             <a:endParaRPr lang="en-US" sz="1400" dirty="0"/>
           </a:p>

</xml_diff>

<commit_message>
Präsentation auf Stand 0.25.0 gebracht (Rollen, Datenschutz, Mitbestimmung, Statistik, Datum)
Co-Authored-By: Claude Opus 5.5 <noreply@anthropic.com>
Claude-Session: https://claude.ai/code/session_01Rb6Lxu6RnQK1jTbYRZcruJ
</commit_message>
<xml_diff>
--- a/docs/LearnTogether-AD_Praesentation.pptx
+++ b/docs/LearnTogether-AD_Praesentation.pptx
@@ -1679,7 +1679,7 @@
           <a:p>
             <a:r>
               <a:rPr lang="en-US" dirty="0"/>
-              <a:t>Im Admin-Bereich gibt es sechs Bereiche mit über 20 Kennzahlen und rund 20 Auswertungen, jeweils mit PDF-Export. Wir betrachten Angebot, Nachfrage, Nutzende, Bewertungen und Datenschutz. Die Abbildung zeigt Beispieldaten. Die Auswertung bleibt aggregiert.</a:t>
+              <a:t>Im Admin-Bereich gibt es sechs Bereiche mit über 20 Kennzahlen und rund 20 Auswertungen, jeweils mit PDF-Export. Wir betrachten Angebot, Nachfrage, Nutzende, Bewertungen und Datenschutz. Die Abbildung zeigt Beispieldaten. Die meisten Auswertungen sind aggregiert. Ranglisten wie die aktivsten Anbietenden zeigen nur Benutzernamen. Ob wir sie im Pilot nutzen, stimmen wir mit dem Betriebsrat ab.</a:t>
             </a:r>
             <a:endParaRPr lang="en-US" dirty="0"/>
           </a:p>
@@ -3716,7 +3716,7 @@
                 <a:ea typeface="Arial" pitchFamily="34" charset="-122"/>
                 <a:cs typeface="Arial" pitchFamily="34" charset="-120"/>
               </a:rPr>
-              <a:t>Wiesbaden, 01.10.2026</a:t>
+              <a:t>Wiesbaden, 02.10.2026</a:t>
             </a:r>
             <a:endParaRPr lang="en-US" sz="1600" dirty="0"/>
           </a:p>
@@ -4079,7 +4079,7 @@
                 <a:ea typeface="Arial" pitchFamily="34" charset="-122"/>
                 <a:cs typeface="Arial" pitchFamily="34" charset="-120"/>
               </a:rPr>
-              <a:t>01.10.2026</a:t>
+              <a:t>02.10.2026</a:t>
             </a:r>
             <a:endParaRPr lang="en-US" sz="1000" dirty="0"/>
           </a:p>
@@ -4551,7 +4551,7 @@
                 <a:ea typeface="Arial" pitchFamily="34" charset="-122"/>
                 <a:cs typeface="Arial" pitchFamily="34" charset="-120"/>
               </a:rPr>
-              <a:t>01.10.2026</a:t>
+              <a:t>02.10.2026</a:t>
             </a:r>
             <a:endParaRPr lang="en-US" sz="1000" dirty="0"/>
           </a:p>
@@ -5155,7 +5155,7 @@
                 <a:ea typeface="Arial" pitchFamily="34" charset="-122"/>
                 <a:cs typeface="Arial" pitchFamily="34" charset="-120"/>
               </a:rPr>
-              <a:t>01.10.2026</a:t>
+              <a:t>02.10.2026</a:t>
             </a:r>
             <a:endParaRPr lang="en-US" sz="1000" dirty="0"/>
           </a:p>
@@ -5759,7 +5759,7 @@
                 <a:ea typeface="Arial" pitchFamily="34" charset="-122"/>
                 <a:cs typeface="Arial" pitchFamily="34" charset="-120"/>
               </a:rPr>
-              <a:t>01.10.2026</a:t>
+              <a:t>02.10.2026</a:t>
             </a:r>
             <a:endParaRPr lang="en-US" sz="1000" dirty="0"/>
           </a:p>
@@ -6363,7 +6363,7 @@
                 <a:ea typeface="Arial" pitchFamily="34" charset="-122"/>
                 <a:cs typeface="Arial" pitchFamily="34" charset="-120"/>
               </a:rPr>
-              <a:t>01.10.2026</a:t>
+              <a:t>02.10.2026</a:t>
             </a:r>
             <a:endParaRPr lang="en-US" sz="1000" dirty="0"/>
           </a:p>
@@ -6967,7 +6967,7 @@
                 <a:ea typeface="Arial" pitchFamily="34" charset="-122"/>
                 <a:cs typeface="Arial" pitchFamily="34" charset="-120"/>
               </a:rPr>
-              <a:t>01.10.2026</a:t>
+              <a:t>02.10.2026</a:t>
             </a:r>
             <a:endParaRPr lang="en-US" sz="1000" dirty="0"/>
           </a:p>
@@ -8169,7 +8169,7 @@
                 <a:ea typeface="Arial" pitchFamily="34" charset="-122"/>
                 <a:cs typeface="Arial" pitchFamily="34" charset="-120"/>
               </a:rPr>
-              <a:t>01.10.2026</a:t>
+              <a:t>02.10.2026</a:t>
             </a:r>
             <a:endParaRPr lang="en-US" sz="1000" dirty="0"/>
           </a:p>
@@ -9223,7 +9223,7 @@
                 <a:ea typeface="Arial" pitchFamily="34" charset="-122"/>
                 <a:cs typeface="Arial" pitchFamily="34" charset="-120"/>
               </a:rPr>
-              <a:t>01.10.2026</a:t>
+              <a:t>02.10.2026</a:t>
             </a:r>
             <a:endParaRPr lang="en-US" sz="1000" dirty="0"/>
           </a:p>
@@ -9459,7 +9459,7 @@
                 <a:ea typeface="Arial" pitchFamily="34" charset="-122"/>
                 <a:cs typeface="Arial" pitchFamily="34" charset="-120"/>
               </a:rPr>
-              <a:t>Anmeldung mit Name und E-Mail</a:t>
+              <a:t>Eigenes Konto, Profilbild freiwillig</a:t>
             </a:r>
             <a:endParaRPr lang="en-US" sz="1400" dirty="0"/>
           </a:p>
@@ -9841,7 +9841,7 @@
                 <a:ea typeface="Arial" pitchFamily="34" charset="-122"/>
                 <a:cs typeface="Arial" pitchFamily="34" charset="-120"/>
               </a:rPr>
-              <a:t>Themen, Arten und Texte pflegen</a:t>
+              <a:t>Themen, Texte, Fotos und Abzeichen pflegen</a:t>
             </a:r>
             <a:endParaRPr lang="en-US" sz="1400" dirty="0"/>
           </a:p>
@@ -9862,7 +9862,7 @@
                 <a:ea typeface="Arial" pitchFamily="34" charset="-122"/>
                 <a:cs typeface="Arial" pitchFamily="34" charset="-120"/>
               </a:rPr>
-              <a:t>Veranstaltungen und Anmeldungen verwalten</a:t>
+              <a:t>Veranstaltungen, Konten und Rechte verwalten</a:t>
             </a:r>
             <a:endParaRPr lang="en-US" sz="1400" dirty="0"/>
           </a:p>
@@ -10109,7 +10109,7 @@
                 <a:ea typeface="Arial" pitchFamily="34" charset="-122"/>
                 <a:cs typeface="Arial" pitchFamily="34" charset="-120"/>
               </a:rPr>
-              <a:t>01.10.2026</a:t>
+              <a:t>02.10.2026</a:t>
             </a:r>
             <a:endParaRPr lang="en-US" sz="1000" dirty="0"/>
           </a:p>
@@ -10762,7 +10762,7 @@
                 <a:ea typeface="Arial" pitchFamily="34" charset="-122"/>
                 <a:cs typeface="Arial" pitchFamily="34" charset="-120"/>
               </a:rPr>
-              <a:t>Ein eigener Statistikbereich zeigt Zahlen, keine Personen</a:t>
+              <a:t>Ein eigener Statistikbereich in sechs Bereichen</a:t>
             </a:r>
             <a:endParaRPr lang="en-US" sz="2000" dirty="0"/>
           </a:p>
@@ -10857,7 +10857,7 @@
                 <a:ea typeface="Arial" pitchFamily="34" charset="-122"/>
                 <a:cs typeface="Arial" pitchFamily="34" charset="-120"/>
               </a:rPr>
-              <a:t>01.10.2026</a:t>
+              <a:t>02.10.2026</a:t>
             </a:r>
             <a:endParaRPr lang="en-US" sz="1000" dirty="0"/>
           </a:p>
@@ -11461,7 +11461,7 @@
                 <a:ea typeface="Arial" pitchFamily="34" charset="-122"/>
                 <a:cs typeface="Arial" pitchFamily="34" charset="-120"/>
               </a:rPr>
-              <a:t>01.10.2026</a:t>
+              <a:t>02.10.2026</a:t>
             </a:r>
             <a:endParaRPr lang="en-US" sz="1000" dirty="0"/>
           </a:p>
@@ -12592,7 +12592,7 @@
                 <a:ea typeface="Arial" pitchFamily="34" charset="-122"/>
                 <a:cs typeface="Arial" pitchFamily="34" charset="-120"/>
               </a:rPr>
-              <a:t>01.10.2026</a:t>
+              <a:t>02.10.2026</a:t>
             </a:r>
             <a:endParaRPr lang="en-US" sz="1000" dirty="0"/>
           </a:p>
@@ -13481,7 +13481,7 @@
                 <a:ea typeface="Arial" pitchFamily="34" charset="-122"/>
                 <a:cs typeface="Arial" pitchFamily="34" charset="-120"/>
               </a:rPr>
-              <a:t>01.10.2026</a:t>
+              <a:t>02.10.2026</a:t>
             </a:r>
             <a:endParaRPr lang="en-US" sz="1000" dirty="0"/>
           </a:p>
@@ -13657,7 +13657,7 @@
                 <a:ea typeface="Arial" pitchFamily="34" charset="-122"/>
                 <a:cs typeface="Arial" pitchFamily="34" charset="-120"/>
               </a:rPr>
-              <a:t>Optional: öffentliches Profil mit Themen, Bio und einzelnen Freigaben.</a:t>
+              <a:t>Optional: öffentliches Profil mit Themen, Bio, Profilbild und Freigaben.</a:t>
             </a:r>
             <a:endParaRPr lang="en-US" sz="1400" dirty="0"/>
           </a:p>
@@ -14359,7 +14359,7 @@
                 <a:ea typeface="Arial" pitchFamily="34" charset="-122"/>
                 <a:cs typeface="Arial" pitchFamily="34" charset="-120"/>
               </a:rPr>
-              <a:t>01.10.2026</a:t>
+              <a:t>02.10.2026</a:t>
             </a:r>
             <a:endParaRPr lang="en-US" sz="1000" dirty="0"/>
           </a:p>
@@ -14535,7 +14535,7 @@
                 <a:ea typeface="Arial" pitchFamily="34" charset="-122"/>
                 <a:cs typeface="Arial" pitchFamily="34" charset="-120"/>
               </a:rPr>
-              <a:t>Die Plattform verarbeitet Name und E-Mail-Adresse.</a:t>
+              <a:t>Die Plattform verarbeitet Name, XV-Nummer, E-Mail-Adresse, Anmeldungen, Bewertungen und freiwillig ein Profilbild.</a:t>
             </a:r>
             <a:endParaRPr lang="en-US" sz="1400" dirty="0"/>
           </a:p>
@@ -14708,7 +14708,7 @@
                 <a:ea typeface="Arial" pitchFamily="34" charset="-122"/>
                 <a:cs typeface="Arial" pitchFamily="34" charset="-120"/>
               </a:rPr>
-              <a:t>Keine Auswertung einzelner Personen, keine Leistungskontrolle</a:t>
+              <a:t>Bewertungen und Abzeichen dienen der Motivation, nicht der Leistungskontrolle</a:t>
             </a:r>
             <a:endParaRPr lang="en-US" sz="1400" dirty="0"/>
           </a:p>
@@ -15149,7 +15149,7 @@
                 <a:ea typeface="Arial" pitchFamily="34" charset="-122"/>
                 <a:cs typeface="Arial" pitchFamily="34" charset="-120"/>
               </a:rPr>
-              <a:t>01.10.2026</a:t>
+              <a:t>02.10.2026</a:t>
             </a:r>
             <a:endParaRPr lang="en-US" sz="1000" dirty="0"/>
           </a:p>
@@ -15822,7 +15822,7 @@
                           <a:ea typeface="Arial" pitchFamily="34" charset="-122"/>
                           <a:cs typeface="Arial" pitchFamily="34" charset="-120"/>
                         </a:rPr>
-                        <a:t>Klare Spielregeln, Rückmeldungen der Teilnehmenden, Termine lassen sich bearbeiten oder entfernen.</a:t>
+                        <a:t>Klare Spielregeln, Bewertungen mit Sternen, Abzeichen für aktive Anbietende, Termine lassen sich bearbeiten oder entfernen.</a:t>
                       </a:r>
                       <a:endParaRPr lang="en-US" sz="1300" dirty="0">
                         <a:latin typeface="Arial" charset="0"/>
@@ -16206,7 +16206,7 @@
                 <a:ea typeface="Arial" pitchFamily="34" charset="-122"/>
                 <a:cs typeface="Arial" pitchFamily="34" charset="-120"/>
               </a:rPr>
-              <a:t>01.10.2026</a:t>
+              <a:t>02.10.2026</a:t>
             </a:r>
             <a:endParaRPr lang="en-US" sz="1000" dirty="0"/>
           </a:p>
@@ -17137,7 +17137,7 @@
                 <a:ea typeface="Arial" pitchFamily="34" charset="-122"/>
                 <a:cs typeface="Arial" pitchFamily="34" charset="-120"/>
               </a:rPr>
-              <a:t>01.10.2026</a:t>
+              <a:t>02.10.2026</a:t>
             </a:r>
             <a:endParaRPr lang="en-US" sz="1000" dirty="0"/>
           </a:p>
@@ -18769,7 +18769,7 @@
                 <a:ea typeface="Arial" pitchFamily="34" charset="-122"/>
                 <a:cs typeface="Arial" pitchFamily="34" charset="-120"/>
               </a:rPr>
-              <a:t>01.10.2026</a:t>
+              <a:t>02.10.2026</a:t>
             </a:r>
             <a:endParaRPr lang="en-US" sz="1000" dirty="0"/>
           </a:p>
@@ -20097,7 +20097,7 @@
                           <a:ea typeface="Arial" pitchFamily="34" charset="-122"/>
                           <a:cs typeface="Arial" pitchFamily="34" charset="-120"/>
                         </a:rPr>
-                        <a:t>Feste Zeitfenster, dienstlich und privat, IDD-Anrechnung als Ziel</a:t>
+                        <a:t>Feste Zeitfenster, dienstlich und privat, Bewertungen und Abzeichen, IDD-Anrechnung als Ziel</a:t>
                       </a:r>
                       <a:endParaRPr lang="en-US" sz="1200" dirty="0">
                         <a:latin typeface="Arial" charset="0"/>
@@ -20391,7 +20391,7 @@
                 <a:ea typeface="Arial" pitchFamily="34" charset="-122"/>
                 <a:cs typeface="Arial" pitchFamily="34" charset="-120"/>
               </a:rPr>
-              <a:t>01.10.2026</a:t>
+              <a:t>02.10.2026</a:t>
             </a:r>
             <a:endParaRPr lang="en-US" sz="1000" dirty="0"/>
           </a:p>
@@ -20810,7 +20810,7 @@
                 <a:ea typeface="Arial" pitchFamily="34" charset="-122"/>
                 <a:cs typeface="Arial" pitchFamily="34" charset="-120"/>
               </a:rPr>
-              <a:t>01.10.2026</a:t>
+              <a:t>02.10.2026</a:t>
             </a:r>
             <a:endParaRPr lang="en-US" sz="1000" dirty="0"/>
           </a:p>
@@ -21600,7 +21600,7 @@
                 <a:ea typeface="Arial" pitchFamily="34" charset="-122"/>
                 <a:cs typeface="Arial" pitchFamily="34" charset="-120"/>
               </a:rPr>
-              <a:t>01.10.2026</a:t>
+              <a:t>02.10.2026</a:t>
             </a:r>
             <a:endParaRPr lang="en-US" sz="1000" dirty="0"/>
           </a:p>
@@ -22402,7 +22402,7 @@
                 <a:ea typeface="Arial" pitchFamily="34" charset="-122"/>
                 <a:cs typeface="Arial" pitchFamily="34" charset="-120"/>
               </a:rPr>
-              <a:t>01.10.2026</a:t>
+              <a:t>02.10.2026</a:t>
             </a:r>
             <a:endParaRPr lang="en-US" sz="1000" dirty="0"/>
           </a:p>
@@ -22920,7 +22920,7 @@
                 <a:ea typeface="Arial" pitchFamily="34" charset="-122"/>
                 <a:cs typeface="Arial" pitchFamily="34" charset="-120"/>
               </a:rPr>
-              <a:t>01.10.2026</a:t>
+              <a:t>02.10.2026</a:t>
             </a:r>
             <a:endParaRPr lang="en-US" sz="1000" dirty="0"/>
           </a:p>
@@ -24247,7 +24247,7 @@
                 <a:ea typeface="Arial" pitchFamily="34" charset="-122"/>
                 <a:cs typeface="Arial" pitchFamily="34" charset="-120"/>
               </a:rPr>
-              <a:t>01.10.2026</a:t>
+              <a:t>02.10.2026</a:t>
             </a:r>
             <a:endParaRPr lang="en-US" sz="1000" dirty="0"/>
           </a:p>
@@ -25311,7 +25311,7 @@
                 <a:ea typeface="Arial" pitchFamily="34" charset="-122"/>
                 <a:cs typeface="Arial" pitchFamily="34" charset="-120"/>
               </a:rPr>
-              <a:t>01.10.2026</a:t>
+              <a:t>02.10.2026</a:t>
             </a:r>
             <a:endParaRPr lang="en-US" sz="1000" dirty="0"/>
           </a:p>
@@ -25985,7 +25985,7 @@
                 <a:ea typeface="Arial" pitchFamily="34" charset="-122"/>
                 <a:cs typeface="Arial" pitchFamily="34" charset="-120"/>
               </a:rPr>
-              <a:t>01.10.2026</a:t>
+              <a:t>02.10.2026</a:t>
             </a:r>
             <a:endParaRPr lang="en-US" sz="1000" dirty="0"/>
           </a:p>

</xml_diff>

<commit_message>
0.28.0: private Sessions 12 Monate, Abzeichen nach Zustimmung, Termin-Update, Benachrichtigungen, SSO-Vorbereitung
- Anonymisierung privater Veranstaltungen nach 12 Monaten
- Abzeichen und Rakete für andere erst nach Zustimmung (Opt-in)
- Mitteilung Termin-Update, Kalenderdatei mit Änderungsstand
- Hinweis auf Mitteilungen auf der Startseite, Browser-Benachrichtigungen (HTTPS)
- Statistik: Reichweite in der Zielgruppe, wiederkehrende Teilnehmende
- SSO-Felder und Konzept; Handbücher, Sicherheitspapier, Präsentation (Pilotziele)

Co-Authored-By: Claude Opus 5.5 <noreply@anthropic.com>
Claude-Session: https://claude.ai/code/session_01Rb6Lxu6RnQK1jTbYRZcruJ
</commit_message>
<xml_diff>
--- a/docs/LearnTogether-AD_Praesentation.pptx
+++ b/docs/LearnTogether-AD_Praesentation.pptx
@@ -1857,7 +1857,7 @@
           <a:p>
             <a:r>
               <a:rPr lang="en-US" dirty="0"/>
-              <a:t>Damit der Nutzen sichtbar wird, schlagen wir messbare Ziele für die ersten sechs Monate vor. Alle Werte liefert die Statistik der Plattform direkt, auch als PDF-Bericht. Die Zielwerte sind ein Vorschlag und werden gemeinsam festgelegt. Der Aufwand ist gering: keine Lizenzkosten, Betrieb auf einem vorhandenen IIS-Server, Termine in Teams. Der Hauptaufwand ist die Betreuung durch VH-VP-TV.</a:t>
+              <a:t>Die Zielwerte leiten sich aus der Zielgruppe von rund 6.000 Personen ab. Wir rechnen mit zwei Monaten Anlauf. Rund 40 Anbietende, also etwa jede 150. Person, bieten im Schnitt zwei bis drei Sessions an. Das ergibt rund 100 Sessions, etwa vier pro Woche. Bei durchschnittlich zehn Teilnehmenden kommen rund 1.000 Teilnahmen zusammen. Bei Ø 45 Minuten sind das rund 750 Lernstunden. Nimmt jede Person im Schnitt gut zweimal teil, erreichen wir etwa 450 Personen, also 7,5 Prozent der Zielgruppe. Mindestens 35 Prozent sollen wiederkommen. Das zeigt, dass das Angebot trägt. Alle Werte liefert die Statistik direkt.</a:t>
             </a:r>
             <a:endParaRPr lang="en-US" dirty="0"/>
           </a:p>
@@ -2033,7 +2033,7 @@
           <a:p>
             <a:r>
               <a:rPr lang="en-US" dirty="0"/>
-              <a:t>Die Anonymisierung ist in der Plattform umgesetzt und läuft automatisch. Öffentlich sichtbar ist nur der Benutzername. Echter Name, XV-Nummer und E-Mail-Adresse sehen nur die betroffene Person und die Administration. Die Daten jeder Veranstaltung bleiben fünf Jahre nach dem Ende gespeichert, ausschließlich für Nachweis und Anrechnung. Das gilt für private und dienstliche Sessions gleichermaßen. Danach werden sie anonymisiert, nur Zähler bleiben. Konten ohne Anmeldung löscht die Plattform nach 24 Monaten automatisch. Zugriff haben nur die Administratoren in VH-VP-TV. Die Daten werden nicht veröffentlicht. Die Fristen und Zwecke stimmen wir mit Datenschutz und Betriebsrat ab.</a:t>
+              <a:t>Die Anonymisierung ist in der Plattform umgesetzt und läuft automatisch. Öffentlich sichtbar ist nur der Benutzername. Echter Name, XV-Nummer und E-Mail-Adresse sehen nur die betroffene Person und die Administration. Die Daten jeder Veranstaltung bleiben fünf Jahre nach dem Ende gespeichert, ausschließlich für Nachweis und Anrechnung. Private Sessions haben keinen Nachweiszweck, ihre Daten werden schon nach 12 Monaten anonymisiert. Danach werden sie anonymisiert, nur Zähler bleiben. Konten ohne Anmeldung löscht die Plattform nach 24 Monaten automatisch. Zugriff haben nur die Administratoren in VH-VP-TV. Die Daten werden nicht veröffentlicht. Die Fristen und Zwecke stimmen wir mit Datenschutz und Betriebsrat ab.</a:t>
             </a:r>
             <a:endParaRPr lang="en-US" dirty="0"/>
           </a:p>
@@ -6297,7 +6297,7 @@
                 <a:ea typeface="Arial" pitchFamily="34" charset="-122"/>
                 <a:cs typeface="Arial" pitchFamily="34" charset="-120"/>
               </a:rPr>
-              <a:t>Absagen erscheinen direkt in der App.</a:t>
+              <a:t>Absage und Termin-Update direkt in der App.</a:t>
             </a:r>
             <a:endParaRPr lang="en-US" sz="1400" dirty="0"/>
           </a:p>
@@ -6745,7 +6745,7 @@
                 <a:ea typeface="Arial" pitchFamily="34" charset="-122"/>
                 <a:cs typeface="Arial" pitchFamily="34" charset="-120"/>
               </a:rPr>
-              <a:t>Sechs Stufen von Bronze bis Diamant. Die Rakete zeigt Expertenstatus im Thema.</a:t>
+              <a:t>Sechs Stufen von Bronze bis Diamant, für andere erst nach Zustimmung sichtbar.</a:t>
             </a:r>
             <a:endParaRPr lang="en-US" sz="1400" dirty="0"/>
           </a:p>
@@ -12675,7 +12675,7 @@
                 <a:ea typeface="Arial" pitchFamily="34" charset="-122"/>
                 <a:cs typeface="Arial" pitchFamily="34" charset="-120"/>
               </a:rPr>
-              <a:t>Klare Zielwerte für sechs Monate (Vorschlag)</a:t>
+              <a:t>Zielwerte für sechs Monate bei rund 6.000 Personen im Außendienst (Vorschlag)</a:t>
             </a:r>
             <a:endParaRPr lang="en-US" sz="2000" dirty="0"/>
           </a:p>
@@ -12809,7 +12809,7 @@
         <p:spPr>
           <a:xfrm>
             <a:off x="530352" y="1508760"/>
-            <a:ext cx="2084832" cy="2331720"/>
+            <a:ext cx="1737360" cy="2331720"/>
           </a:xfrm>
           <a:prstGeom prst="rect">
             <a:avLst/>
@@ -12833,8 +12833,8 @@
         </p:nvSpPr>
         <p:spPr>
           <a:xfrm>
-            <a:off x="713232" y="1645920"/>
-            <a:ext cx="1737360" cy="822960"/>
+            <a:off x="694944" y="1645920"/>
+            <a:ext cx="1463040" cy="822960"/>
           </a:xfrm>
           <a:prstGeom prst="rect">
             <a:avLst/>
@@ -12850,7 +12850,7 @@
               <a:buNone/>
             </a:pPr>
             <a:r>
-              <a:rPr lang="en-US" sz="3600" b="1" dirty="0">
+              <a:rPr lang="en-US" sz="3200" b="1" dirty="0">
                 <a:solidFill>
                   <a:srgbClr val="FFFFFF"/>
                 </a:solidFill>
@@ -12858,9 +12858,9 @@
                 <a:ea typeface="Arial" pitchFamily="34" charset="-122"/>
                 <a:cs typeface="Arial" pitchFamily="34" charset="-120"/>
               </a:rPr>
-              <a:t>500</a:t>
-            </a:r>
-            <a:endParaRPr lang="en-US" sz="3600" dirty="0"/>
+              <a:t>450</a:t>
+            </a:r>
+            <a:endParaRPr lang="en-US" sz="3200" dirty="0"/>
           </a:p>
         </p:txBody>
       </p:sp>
@@ -12872,8 +12872,8 @@
         </p:nvSpPr>
         <p:spPr>
           <a:xfrm>
-            <a:off x="713232" y="2514600"/>
-            <a:ext cx="1783080" cy="548640"/>
+            <a:off x="694944" y="2514600"/>
+            <a:ext cx="1508760" cy="548640"/>
           </a:xfrm>
           <a:prstGeom prst="rect">
             <a:avLst/>
@@ -12889,7 +12889,7 @@
               <a:buNone/>
             </a:pPr>
             <a:r>
-              <a:rPr lang="en-US" sz="1500" b="1" dirty="0">
+              <a:rPr lang="en-US" sz="1400" b="1" dirty="0">
                 <a:solidFill>
                   <a:srgbClr val="00DCDC"/>
                 </a:solidFill>
@@ -12897,9 +12897,9 @@
                 <a:ea typeface="Arial" pitchFamily="34" charset="-122"/>
                 <a:cs typeface="Arial" pitchFamily="34" charset="-120"/>
               </a:rPr>
-              <a:t>Lernstunden</a:t>
-            </a:r>
-            <a:endParaRPr lang="en-US" sz="1500" dirty="0"/>
+              <a:t>Erreichte Personen</a:t>
+            </a:r>
+            <a:endParaRPr lang="en-US" sz="1400" dirty="0"/>
           </a:p>
         </p:txBody>
       </p:sp>
@@ -12911,8 +12911,8 @@
         </p:nvSpPr>
         <p:spPr>
           <a:xfrm>
-            <a:off x="713232" y="3063240"/>
-            <a:ext cx="1783080" cy="640080"/>
+            <a:off x="694944" y="3063240"/>
+            <a:ext cx="1508760" cy="640080"/>
           </a:xfrm>
           <a:prstGeom prst="rect">
             <a:avLst/>
@@ -12936,7 +12936,7 @@
                 <a:ea typeface="Arial" pitchFamily="34" charset="-122"/>
                 <a:cs typeface="Arial" pitchFamily="34" charset="-120"/>
               </a:rPr>
-              <a:t>Teilnahmen mal Dauer</a:t>
+              <a:t>7,5 % der Zielgruppe</a:t>
             </a:r>
             <a:endParaRPr lang="en-US" sz="1200" dirty="0"/>
           </a:p>
@@ -12950,8 +12950,8 @@
         </p:nvSpPr>
         <p:spPr>
           <a:xfrm>
-            <a:off x="2798064" y="1508760"/>
-            <a:ext cx="2084832" cy="2331720"/>
+            <a:off x="2414016" y="1508760"/>
+            <a:ext cx="1737360" cy="2331720"/>
           </a:xfrm>
           <a:prstGeom prst="rect">
             <a:avLst/>
@@ -12975,8 +12975,8 @@
         </p:nvSpPr>
         <p:spPr>
           <a:xfrm>
-            <a:off x="2980944" y="1645920"/>
-            <a:ext cx="1737360" cy="822960"/>
+            <a:off x="2578608" y="1645920"/>
+            <a:ext cx="1463040" cy="822960"/>
           </a:xfrm>
           <a:prstGeom prst="rect">
             <a:avLst/>
@@ -12992,17 +12992,17 @@
               <a:buNone/>
             </a:pPr>
             <a:r>
-              <a:rPr lang="en-US" sz="3600" b="1" dirty="0">
-                <a:solidFill>
-                  <a:srgbClr val="001957"/>
-                </a:solidFill>
-                <a:latin typeface="Arial" pitchFamily="34" charset="0"/>
-                <a:ea typeface="Arial" pitchFamily="34" charset="-122"/>
-                <a:cs typeface="Arial" pitchFamily="34" charset="-120"/>
-              </a:rPr>
-              <a:t>250</a:t>
-            </a:r>
-            <a:endParaRPr lang="en-US" sz="3600" dirty="0"/>
+              <a:rPr lang="en-US" sz="3200" b="1" dirty="0">
+                <a:solidFill>
+                  <a:srgbClr val="001957"/>
+                </a:solidFill>
+                <a:latin typeface="Arial" pitchFamily="34" charset="0"/>
+                <a:ea typeface="Arial" pitchFamily="34" charset="-122"/>
+                <a:cs typeface="Arial" pitchFamily="34" charset="-120"/>
+              </a:rPr>
+              <a:t>750</a:t>
+            </a:r>
+            <a:endParaRPr lang="en-US" sz="3200" dirty="0"/>
           </a:p>
         </p:txBody>
       </p:sp>
@@ -13014,8 +13014,8 @@
         </p:nvSpPr>
         <p:spPr>
           <a:xfrm>
-            <a:off x="2980944" y="2514600"/>
-            <a:ext cx="1783080" cy="548640"/>
+            <a:off x="2578608" y="2514600"/>
+            <a:ext cx="1508760" cy="548640"/>
           </a:xfrm>
           <a:prstGeom prst="rect">
             <a:avLst/>
@@ -13031,17 +13031,17 @@
               <a:buNone/>
             </a:pPr>
             <a:r>
-              <a:rPr lang="en-US" sz="1500" b="1" dirty="0">
-                <a:solidFill>
-                  <a:srgbClr val="001957"/>
-                </a:solidFill>
-                <a:latin typeface="Arial" pitchFamily="34" charset="0"/>
-                <a:ea typeface="Arial" pitchFamily="34" charset="-122"/>
-                <a:cs typeface="Arial" pitchFamily="34" charset="-120"/>
-              </a:rPr>
-              <a:t>Erreichte Personen</a:t>
-            </a:r>
-            <a:endParaRPr lang="en-US" sz="1500" dirty="0"/>
+              <a:rPr lang="en-US" sz="1400" b="1" dirty="0">
+                <a:solidFill>
+                  <a:srgbClr val="001957"/>
+                </a:solidFill>
+                <a:latin typeface="Arial" pitchFamily="34" charset="0"/>
+                <a:ea typeface="Arial" pitchFamily="34" charset="-122"/>
+                <a:cs typeface="Arial" pitchFamily="34" charset="-120"/>
+              </a:rPr>
+              <a:t>Lernstunden</a:t>
+            </a:r>
+            <a:endParaRPr lang="en-US" sz="1400" dirty="0"/>
           </a:p>
         </p:txBody>
       </p:sp>
@@ -13053,8 +13053,8 @@
         </p:nvSpPr>
         <p:spPr>
           <a:xfrm>
-            <a:off x="2980944" y="3063240"/>
-            <a:ext cx="1783080" cy="640080"/>
+            <a:off x="2578608" y="3063240"/>
+            <a:ext cx="1508760" cy="640080"/>
           </a:xfrm>
           <a:prstGeom prst="rect">
             <a:avLst/>
@@ -13078,7 +13078,7 @@
                 <a:ea typeface="Arial" pitchFamily="34" charset="-122"/>
                 <a:cs typeface="Arial" pitchFamily="34" charset="-120"/>
               </a:rPr>
-              <a:t>mindestens eine Teilnahme</a:t>
+              <a:t>Teilnahmen mal Dauer</a:t>
             </a:r>
             <a:endParaRPr lang="en-US" sz="1200" dirty="0"/>
           </a:p>
@@ -13092,8 +13092,8 @@
         </p:nvSpPr>
         <p:spPr>
           <a:xfrm>
-            <a:off x="5065776" y="1508760"/>
-            <a:ext cx="2084832" cy="2331720"/>
+            <a:off x="4297680" y="1508760"/>
+            <a:ext cx="1737360" cy="2331720"/>
           </a:xfrm>
           <a:prstGeom prst="rect">
             <a:avLst/>
@@ -13117,8 +13117,8 @@
         </p:nvSpPr>
         <p:spPr>
           <a:xfrm>
-            <a:off x="5248656" y="1645920"/>
-            <a:ext cx="1737360" cy="822960"/>
+            <a:off x="4462272" y="1645920"/>
+            <a:ext cx="1463040" cy="822960"/>
           </a:xfrm>
           <a:prstGeom prst="rect">
             <a:avLst/>
@@ -13134,17 +13134,17 @@
               <a:buNone/>
             </a:pPr>
             <a:r>
-              <a:rPr lang="en-US" sz="3600" b="1" dirty="0">
-                <a:solidFill>
-                  <a:srgbClr val="001957"/>
-                </a:solidFill>
-                <a:latin typeface="Arial" pitchFamily="34" charset="0"/>
-                <a:ea typeface="Arial" pitchFamily="34" charset="-122"/>
-                <a:cs typeface="Arial" pitchFamily="34" charset="-120"/>
-              </a:rPr>
-              <a:t>60</a:t>
-            </a:r>
-            <a:endParaRPr lang="en-US" sz="3600" dirty="0"/>
+              <a:rPr lang="en-US" sz="3200" b="1" dirty="0">
+                <a:solidFill>
+                  <a:srgbClr val="001957"/>
+                </a:solidFill>
+                <a:latin typeface="Arial" pitchFamily="34" charset="0"/>
+                <a:ea typeface="Arial" pitchFamily="34" charset="-122"/>
+                <a:cs typeface="Arial" pitchFamily="34" charset="-120"/>
+              </a:rPr>
+              <a:t>100</a:t>
+            </a:r>
+            <a:endParaRPr lang="en-US" sz="3200" dirty="0"/>
           </a:p>
         </p:txBody>
       </p:sp>
@@ -13156,8 +13156,8 @@
         </p:nvSpPr>
         <p:spPr>
           <a:xfrm>
-            <a:off x="5248656" y="2514600"/>
-            <a:ext cx="1783080" cy="548640"/>
+            <a:off x="4462272" y="2514600"/>
+            <a:ext cx="1508760" cy="548640"/>
           </a:xfrm>
           <a:prstGeom prst="rect">
             <a:avLst/>
@@ -13173,7 +13173,7 @@
               <a:buNone/>
             </a:pPr>
             <a:r>
-              <a:rPr lang="en-US" sz="1500" b="1" dirty="0">
+              <a:rPr lang="en-US" sz="1400" b="1" dirty="0">
                 <a:solidFill>
                   <a:srgbClr val="001957"/>
                 </a:solidFill>
@@ -13183,7 +13183,7 @@
               </a:rPr>
               <a:t>Sessions</a:t>
             </a:r>
-            <a:endParaRPr lang="en-US" sz="1500" dirty="0"/>
+            <a:endParaRPr lang="en-US" sz="1400" dirty="0"/>
           </a:p>
         </p:txBody>
       </p:sp>
@@ -13195,8 +13195,8 @@
         </p:nvSpPr>
         <p:spPr>
           <a:xfrm>
-            <a:off x="5248656" y="3063240"/>
-            <a:ext cx="1783080" cy="640080"/>
+            <a:off x="4462272" y="3063240"/>
+            <a:ext cx="1508760" cy="640080"/>
           </a:xfrm>
           <a:prstGeom prst="rect">
             <a:avLst/>
@@ -13220,7 +13220,7 @@
                 <a:ea typeface="Arial" pitchFamily="34" charset="-122"/>
                 <a:cs typeface="Arial" pitchFamily="34" charset="-120"/>
               </a:rPr>
-              <a:t>durchgeführt, dienstlich und privat</a:t>
+              <a:t>rund 4 pro Woche</a:t>
             </a:r>
             <a:endParaRPr lang="en-US" sz="1200" dirty="0"/>
           </a:p>
@@ -13234,8 +13234,8 @@
         </p:nvSpPr>
         <p:spPr>
           <a:xfrm>
-            <a:off x="7333488" y="1508760"/>
-            <a:ext cx="2084832" cy="2331720"/>
+            <a:off x="6181344" y="1508760"/>
+            <a:ext cx="1737360" cy="2331720"/>
           </a:xfrm>
           <a:prstGeom prst="rect">
             <a:avLst/>
@@ -13259,8 +13259,8 @@
         </p:nvSpPr>
         <p:spPr>
           <a:xfrm>
-            <a:off x="7516368" y="1645920"/>
-            <a:ext cx="1737360" cy="822960"/>
+            <a:off x="6345936" y="1645920"/>
+            <a:ext cx="1463040" cy="822960"/>
           </a:xfrm>
           <a:prstGeom prst="rect">
             <a:avLst/>
@@ -13276,17 +13276,17 @@
               <a:buNone/>
             </a:pPr>
             <a:r>
-              <a:rPr lang="en-US" sz="3600" b="1" dirty="0">
-                <a:solidFill>
-                  <a:srgbClr val="001957"/>
-                </a:solidFill>
-                <a:latin typeface="Arial" pitchFamily="34" charset="0"/>
-                <a:ea typeface="Arial" pitchFamily="34" charset="-122"/>
-                <a:cs typeface="Arial" pitchFamily="34" charset="-120"/>
-              </a:rPr>
-              <a:t>20</a:t>
-            </a:r>
-            <a:endParaRPr lang="en-US" sz="3600" dirty="0"/>
+              <a:rPr lang="en-US" sz="3200" b="1" dirty="0">
+                <a:solidFill>
+                  <a:srgbClr val="001957"/>
+                </a:solidFill>
+                <a:latin typeface="Arial" pitchFamily="34" charset="0"/>
+                <a:ea typeface="Arial" pitchFamily="34" charset="-122"/>
+                <a:cs typeface="Arial" pitchFamily="34" charset="-120"/>
+              </a:rPr>
+              <a:t>40</a:t>
+            </a:r>
+            <a:endParaRPr lang="en-US" sz="3200" dirty="0"/>
           </a:p>
         </p:txBody>
       </p:sp>
@@ -13298,8 +13298,8 @@
         </p:nvSpPr>
         <p:spPr>
           <a:xfrm>
-            <a:off x="7516368" y="2514600"/>
-            <a:ext cx="1783080" cy="548640"/>
+            <a:off x="6345936" y="2514600"/>
+            <a:ext cx="1508760" cy="548640"/>
           </a:xfrm>
           <a:prstGeom prst="rect">
             <a:avLst/>
@@ -13315,7 +13315,7 @@
               <a:buNone/>
             </a:pPr>
             <a:r>
-              <a:rPr lang="en-US" sz="1500" b="1" dirty="0">
+              <a:rPr lang="en-US" sz="1400" b="1" dirty="0">
                 <a:solidFill>
                   <a:srgbClr val="001957"/>
                 </a:solidFill>
@@ -13325,7 +13325,7 @@
               </a:rPr>
               <a:t>Anbietende</a:t>
             </a:r>
-            <a:endParaRPr lang="en-US" sz="1500" dirty="0"/>
+            <a:endParaRPr lang="en-US" sz="1400" dirty="0"/>
           </a:p>
         </p:txBody>
       </p:sp>
@@ -13337,8 +13337,8 @@
         </p:nvSpPr>
         <p:spPr>
           <a:xfrm>
-            <a:off x="7516368" y="3063240"/>
-            <a:ext cx="1783080" cy="640080"/>
+            <a:off x="6345936" y="3063240"/>
+            <a:ext cx="1508760" cy="640080"/>
           </a:xfrm>
           <a:prstGeom prst="rect">
             <a:avLst/>
@@ -13376,8 +13376,8 @@
         </p:nvSpPr>
         <p:spPr>
           <a:xfrm>
-            <a:off x="9601200" y="1508760"/>
-            <a:ext cx="2084832" cy="2331720"/>
+            <a:off x="8065008" y="1508760"/>
+            <a:ext cx="1737360" cy="2331720"/>
           </a:xfrm>
           <a:prstGeom prst="rect">
             <a:avLst/>
@@ -13401,8 +13401,8 @@
         </p:nvSpPr>
         <p:spPr>
           <a:xfrm>
-            <a:off x="9784080" y="1645920"/>
-            <a:ext cx="1737360" cy="822960"/>
+            <a:off x="8229600" y="1645920"/>
+            <a:ext cx="1463040" cy="822960"/>
           </a:xfrm>
           <a:prstGeom prst="rect">
             <a:avLst/>
@@ -13418,17 +13418,17 @@
               <a:buNone/>
             </a:pPr>
             <a:r>
-              <a:rPr lang="en-US" sz="3600" b="1" dirty="0">
-                <a:solidFill>
-                  <a:srgbClr val="001957"/>
-                </a:solidFill>
-                <a:latin typeface="Arial" pitchFamily="34" charset="0"/>
-                <a:ea typeface="Arial" pitchFamily="34" charset="-122"/>
-                <a:cs typeface="Arial" pitchFamily="34" charset="-120"/>
-              </a:rPr>
-              <a:t>4,0</a:t>
-            </a:r>
-            <a:endParaRPr lang="en-US" sz="3600" dirty="0"/>
+              <a:rPr lang="en-US" sz="3200" b="1" dirty="0">
+                <a:solidFill>
+                  <a:srgbClr val="001957"/>
+                </a:solidFill>
+                <a:latin typeface="Arial" pitchFamily="34" charset="0"/>
+                <a:ea typeface="Arial" pitchFamily="34" charset="-122"/>
+                <a:cs typeface="Arial" pitchFamily="34" charset="-120"/>
+              </a:rPr>
+              <a:t>35 %</a:t>
+            </a:r>
+            <a:endParaRPr lang="en-US" sz="3200" dirty="0"/>
           </a:p>
         </p:txBody>
       </p:sp>
@@ -13440,8 +13440,8 @@
         </p:nvSpPr>
         <p:spPr>
           <a:xfrm>
-            <a:off x="9784080" y="2514600"/>
-            <a:ext cx="1783080" cy="548640"/>
+            <a:off x="8229600" y="2514600"/>
+            <a:ext cx="1508760" cy="548640"/>
           </a:xfrm>
           <a:prstGeom prst="rect">
             <a:avLst/>
@@ -13457,7 +13457,149 @@
               <a:buNone/>
             </a:pPr>
             <a:r>
-              <a:rPr lang="en-US" sz="1500" b="1" dirty="0">
+              <a:rPr lang="en-US" sz="1400" b="1" dirty="0">
+                <a:solidFill>
+                  <a:srgbClr val="001957"/>
+                </a:solidFill>
+                <a:latin typeface="Arial" pitchFamily="34" charset="0"/>
+                <a:ea typeface="Arial" pitchFamily="34" charset="-122"/>
+                <a:cs typeface="Arial" pitchFamily="34" charset="-120"/>
+              </a:rPr>
+              <a:t>Wiederkehrend</a:t>
+            </a:r>
+            <a:endParaRPr lang="en-US" sz="1400" dirty="0"/>
+          </a:p>
+        </p:txBody>
+      </p:sp>
+      <p:sp>
+        <p:nvSpPr>
+          <p:cNvPr id="27" name="Text 23"/>
+          <p:cNvSpPr txBox="1"/>
+          <p:nvPr/>
+        </p:nvSpPr>
+        <p:spPr>
+          <a:xfrm>
+            <a:off x="8229600" y="3063240"/>
+            <a:ext cx="1508760" cy="640080"/>
+          </a:xfrm>
+          <a:prstGeom prst="rect">
+            <a:avLst/>
+          </a:prstGeom>
+          <a:noFill/>
+          <a:ln/>
+        </p:spPr>
+        <p:txBody>
+          <a:bodyPr wrap="square" lIns="0" tIns="0" rIns="0" bIns="0" rtlCol="0" anchor="t"/>
+          <a:lstStyle/>
+          <a:p>
+            <a:pPr indent="0" marL="0">
+              <a:buNone/>
+            </a:pPr>
+            <a:r>
+              <a:rPr lang="en-US" sz="1200" dirty="0">
+                <a:solidFill>
+                  <a:srgbClr val="001957"/>
+                </a:solidFill>
+                <a:latin typeface="Arial" pitchFamily="34" charset="0"/>
+                <a:ea typeface="Arial" pitchFamily="34" charset="-122"/>
+                <a:cs typeface="Arial" pitchFamily="34" charset="-120"/>
+              </a:rPr>
+              <a:t>mindestens 2 Teilnahmen</a:t>
+            </a:r>
+            <a:endParaRPr lang="en-US" sz="1200" dirty="0"/>
+          </a:p>
+        </p:txBody>
+      </p:sp>
+      <p:sp>
+        <p:nvSpPr>
+          <p:cNvPr id="28" name="Shape 24"/>
+          <p:cNvSpPr/>
+          <p:nvPr/>
+        </p:nvSpPr>
+        <p:spPr>
+          <a:xfrm>
+            <a:off x="9948672" y="1508760"/>
+            <a:ext cx="1737360" cy="2331720"/>
+          </a:xfrm>
+          <a:prstGeom prst="rect">
+            <a:avLst/>
+          </a:prstGeom>
+          <a:solidFill>
+            <a:srgbClr val="F5F5F5"/>
+          </a:solidFill>
+          <a:ln w="12700">
+            <a:solidFill>
+              <a:srgbClr val="F5F5F5"/>
+            </a:solidFill>
+            <a:prstDash val="solid"/>
+          </a:ln>
+        </p:spPr>
+      </p:sp>
+      <p:sp>
+        <p:nvSpPr>
+          <p:cNvPr id="29" name="Text 25"/>
+          <p:cNvSpPr txBox="1"/>
+          <p:nvPr/>
+        </p:nvSpPr>
+        <p:spPr>
+          <a:xfrm>
+            <a:off x="10113264" y="1645920"/>
+            <a:ext cx="1463040" cy="822960"/>
+          </a:xfrm>
+          <a:prstGeom prst="rect">
+            <a:avLst/>
+          </a:prstGeom>
+          <a:noFill/>
+          <a:ln/>
+        </p:spPr>
+        <p:txBody>
+          <a:bodyPr wrap="square" lIns="0" tIns="0" rIns="0" bIns="0" rtlCol="0" anchor="t"/>
+          <a:lstStyle/>
+          <a:p>
+            <a:pPr indent="0" marL="0">
+              <a:buNone/>
+            </a:pPr>
+            <a:r>
+              <a:rPr lang="en-US" sz="3200" b="1" dirty="0">
+                <a:solidFill>
+                  <a:srgbClr val="001957"/>
+                </a:solidFill>
+                <a:latin typeface="Arial" pitchFamily="34" charset="0"/>
+                <a:ea typeface="Arial" pitchFamily="34" charset="-122"/>
+                <a:cs typeface="Arial" pitchFamily="34" charset="-120"/>
+              </a:rPr>
+              <a:t>4,2</a:t>
+            </a:r>
+            <a:endParaRPr lang="en-US" sz="3200" dirty="0"/>
+          </a:p>
+        </p:txBody>
+      </p:sp>
+      <p:sp>
+        <p:nvSpPr>
+          <p:cNvPr id="30" name="Text 26"/>
+          <p:cNvSpPr txBox="1"/>
+          <p:nvPr/>
+        </p:nvSpPr>
+        <p:spPr>
+          <a:xfrm>
+            <a:off x="10113264" y="2514600"/>
+            <a:ext cx="1508760" cy="548640"/>
+          </a:xfrm>
+          <a:prstGeom prst="rect">
+            <a:avLst/>
+          </a:prstGeom>
+          <a:noFill/>
+          <a:ln/>
+        </p:spPr>
+        <p:txBody>
+          <a:bodyPr wrap="square" lIns="0" tIns="0" rIns="0" bIns="0" rtlCol="0" anchor="t"/>
+          <a:lstStyle/>
+          <a:p>
+            <a:pPr indent="0" marL="0">
+              <a:buNone/>
+            </a:pPr>
+            <a:r>
+              <a:rPr lang="en-US" sz="1400" b="1" dirty="0">
                 <a:solidFill>
                   <a:srgbClr val="001957"/>
                 </a:solidFill>
@@ -13467,20 +13609,20 @@
               </a:rPr>
               <a:t>Zufriedenheit</a:t>
             </a:r>
-            <a:endParaRPr lang="en-US" sz="1500" dirty="0"/>
-          </a:p>
-        </p:txBody>
-      </p:sp>
-      <p:sp>
-        <p:nvSpPr>
-          <p:cNvPr id="27" name="Text 23"/>
-          <p:cNvSpPr txBox="1"/>
-          <p:nvPr/>
-        </p:nvSpPr>
-        <p:spPr>
-          <a:xfrm>
-            <a:off x="9784080" y="3063240"/>
-            <a:ext cx="1783080" cy="640080"/>
+            <a:endParaRPr lang="en-US" sz="1400" dirty="0"/>
+          </a:p>
+        </p:txBody>
+      </p:sp>
+      <p:sp>
+        <p:nvSpPr>
+          <p:cNvPr id="31" name="Text 27"/>
+          <p:cNvSpPr txBox="1"/>
+          <p:nvPr/>
+        </p:nvSpPr>
+        <p:spPr>
+          <a:xfrm>
+            <a:off x="10113264" y="3063240"/>
+            <a:ext cx="1508760" cy="640080"/>
           </a:xfrm>
           <a:prstGeom prst="rect">
             <a:avLst/>
@@ -13512,7 +13654,7 @@
       </p:sp>
       <p:sp>
         <p:nvSpPr>
-          <p:cNvPr id="28" name="Shape 24"/>
+          <p:cNvPr id="32" name="Shape 28"/>
           <p:cNvSpPr/>
           <p:nvPr/>
         </p:nvSpPr>
@@ -13537,7 +13679,7 @@
       </p:sp>
       <p:pic>
         <p:nvPicPr>
-          <p:cNvPr id="29" name="Image 1" descr="/tmp/deck/ic/target_m.png">    </p:cNvPr>
+          <p:cNvPr id="33" name="Image 1" descr="/tmp/deck/ic/target_m.png">    </p:cNvPr>
           <p:cNvPicPr>
             <a:picLocks noChangeAspect="1"/>
           </p:cNvPicPr>
@@ -13561,7 +13703,7 @@
       </p:pic>
       <p:sp>
         <p:nvSpPr>
-          <p:cNvPr id="30" name="Text 25"/>
+          <p:cNvPr id="34" name="Text 29"/>
           <p:cNvSpPr txBox="1"/>
           <p:nvPr/>
         </p:nvSpPr>
@@ -13600,7 +13742,7 @@
       </p:sp>
       <p:sp>
         <p:nvSpPr>
-          <p:cNvPr id="31" name="Text 26"/>
+          <p:cNvPr id="35" name="Text 30"/>
           <p:cNvSpPr txBox="1"/>
           <p:nvPr/>
         </p:nvSpPr>
@@ -13635,7 +13777,7 @@
                 <a:ea typeface="Arial" pitchFamily="34" charset="-122"/>
                 <a:cs typeface="Arial" pitchFamily="34" charset="-120"/>
               </a:rPr>
-              <a:t>Alle Werte in der Statistik und als PDF-Bericht</a:t>
+              <a:t>Zwischenstand nach 3 Monaten: 200 Personen, 25 Anbietende</a:t>
             </a:r>
             <a:endParaRPr lang="en-US" sz="1400" dirty="0"/>
           </a:p>
@@ -13656,7 +13798,7 @@
                 <a:ea typeface="Arial" pitchFamily="34" charset="-122"/>
                 <a:cs typeface="Arial" pitchFamily="34" charset="-120"/>
               </a:rPr>
-              <a:t>Monatlicher Bericht an das Management</a:t>
+              <a:t>Monatlicher Bericht an das Management (PDF)</a:t>
             </a:r>
             <a:endParaRPr lang="en-US" sz="1400" dirty="0"/>
           </a:p>
@@ -13677,7 +13819,7 @@
                 <a:ea typeface="Arial" pitchFamily="34" charset="-122"/>
                 <a:cs typeface="Arial" pitchFamily="34" charset="-120"/>
               </a:rPr>
-              <a:t>Nach sechs Monaten: Entscheidung über den Ausbau</a:t>
+              <a:t>Nach 6 Monaten: Entscheidung über den Ausbau</a:t>
             </a:r>
             <a:endParaRPr lang="en-US" sz="1400" dirty="0"/>
           </a:p>
@@ -13685,7 +13827,7 @@
       </p:sp>
       <p:sp>
         <p:nvSpPr>
-          <p:cNvPr id="32" name="Shape 27"/>
+          <p:cNvPr id="36" name="Shape 31"/>
           <p:cNvSpPr/>
           <p:nvPr/>
         </p:nvSpPr>
@@ -13710,7 +13852,7 @@
       </p:sp>
       <p:pic>
         <p:nvPicPr>
-          <p:cNvPr id="33" name="Image 2" descr="/tmp/deck/ic/building_m.png">    </p:cNvPr>
+          <p:cNvPr id="37" name="Image 2" descr="/tmp/deck/ic/building_m.png">    </p:cNvPr>
           <p:cNvPicPr>
             <a:picLocks noChangeAspect="1"/>
           </p:cNvPicPr>
@@ -13734,7 +13876,7 @@
       </p:pic>
       <p:sp>
         <p:nvSpPr>
-          <p:cNvPr id="34" name="Text 28"/>
+          <p:cNvPr id="38" name="Text 32"/>
           <p:cNvSpPr txBox="1"/>
           <p:nvPr/>
         </p:nvSpPr>
@@ -13773,7 +13915,7 @@
       </p:sp>
       <p:sp>
         <p:nvSpPr>
-          <p:cNvPr id="35" name="Text 29"/>
+          <p:cNvPr id="39" name="Text 33"/>
           <p:cNvSpPr txBox="1"/>
           <p:nvPr/>
         </p:nvSpPr>
@@ -14849,7 +14991,7 @@
                 <a:ea typeface="Arial" pitchFamily="34" charset="-122"/>
                 <a:cs typeface="Arial" pitchFamily="34" charset="-120"/>
               </a:rPr>
-              <a:t>Öffentlich nur der Benutzername, Anonymisierung nach fünf Jahren</a:t>
+              <a:t>Öffentlich nur der Benutzername, Anonymisierung nach fünf Jahren oder 12 Monaten</a:t>
             </a:r>
             <a:endParaRPr lang="en-US" sz="2000" dirty="0"/>
           </a:p>
@@ -15099,7 +15241,7 @@
                 <a:ea typeface="Arial" pitchFamily="34" charset="-122"/>
                 <a:cs typeface="Arial" pitchFamily="34" charset="-120"/>
               </a:rPr>
-              <a:t>Standard: nur der frei gewählte Benutzername mit Abzeichen, das sich ausblenden lässt.</a:t>
+              <a:t>Standard: nur der frei gewählte Benutzername. Abzeichen erst nach Zustimmung.</a:t>
             </a:r>
             <a:endParaRPr lang="en-US" sz="1400" dirty="0"/>
           </a:p>
@@ -15272,7 +15414,7 @@
                 <a:ea typeface="Arial" pitchFamily="34" charset="-122"/>
                 <a:cs typeface="Arial" pitchFamily="34" charset="-120"/>
               </a:rPr>
-              <a:t>Daten bleiben fünf Jahre nach dem Ende gespeichert.</a:t>
+              <a:t>Dienstlich: fünf Jahre nach dem Ende gespeichert.</a:t>
             </a:r>
             <a:endParaRPr lang="en-US" sz="1400" dirty="0"/>
           </a:p>
@@ -15294,6 +15436,27 @@
                 <a:cs typeface="Arial" pitchFamily="34" charset="-120"/>
               </a:rPr>
               <a:t>Zweck: ausschließlich Nachweis und Anrechnung (IDD).</a:t>
+            </a:r>
+            <a:endParaRPr lang="en-US" sz="1400" dirty="0"/>
+          </a:p>
+          <a:p>
+            <a:pPr marL="342900" indent="-342900">
+              <a:spcAft>
+                <a:spcPts val="800"/>
+              </a:spcAft>
+              <a:buSzPct val="100000"/>
+              <a:buChar char="•"/>
+            </a:pPr>
+            <a:r>
+              <a:rPr lang="en-US" sz="1400" dirty="0">
+                <a:solidFill>
+                  <a:srgbClr val="FFFFFF"/>
+                </a:solidFill>
+                <a:latin typeface="Arial" pitchFamily="34" charset="0"/>
+                <a:ea typeface="Arial" pitchFamily="34" charset="-122"/>
+                <a:cs typeface="Arial" pitchFamily="34" charset="-120"/>
+              </a:rPr>
+              <a:t>Privat: nur 12 Monate.</a:t>
             </a:r>
             <a:endParaRPr lang="en-US" sz="1400" dirty="0"/>
           </a:p>
@@ -16040,7 +16203,7 @@
                 <a:ea typeface="Arial" pitchFamily="34" charset="-122"/>
                 <a:cs typeface="Arial" pitchFamily="34" charset="-120"/>
               </a:rPr>
-              <a:t>Profil, Profilbild und Abzeichen freiwillig</a:t>
+              <a:t>Profil und Profilbild freiwillig, Abzeichen nur nach Zustimmung</a:t>
             </a:r>
             <a:endParaRPr lang="en-US" sz="1400" dirty="0"/>
           </a:p>

</xml_diff>

<commit_message>
0.30.0: Agenda-Editor für IDD, IDD-Optionen über dem Termin, IDD-Archiv als eigene Seite
- Agenda im Popup: Inhalte, Dauer, IDD-Bildungszeit; anpassen, hinzufügen, löschen, verschieben
- Fehler: IDD-Optionen fehlten nach eigener Freischaltung bzw. für Admins
- Jahresauswahl ohne Rahmen, Reihenfolge der Profil-Freigaben, Handbücher und Präsentation

Co-Authored-By: Claude Opus 5.5 <noreply@anthropic.com>
Claude-Session: https://claude.ai/code/session_01Rb6Lxu6RnQK1jTbYRZcruJ
</commit_message>
<xml_diff>
--- a/docs/LearnTogether-AD_Praesentation.pptx
+++ b/docs/LearnTogether-AD_Praesentation.pptx
@@ -2034,7 +2034,7 @@
           <a:p>
             <a:r>
               <a:rPr lang="en-US" dirty="0"/>
-              <a:t>So läuft eine IDD-Veranstaltung. Erstens: Freigeschaltete Anbietende setzen beim Anlegen den IDD-Haken, tragen den IDD-Titel ein und prüfen die IDD-Zeit. Die App prüft den Titel und erzeugt die Agenda. Zweitens: Teilnehmende sehen im Katalog Dauer und IDD-Zeit getrennt. Drittens: Nach der Session bestätigen die Anbietenden die Teilnahme innerhalb von 14 Tagen, danach die Administration. Viertens: Im IDD-Cockpit sehen Teilnehmende ihre Zeit je Kalenderjahr und laden den PDF-Nachweis. Die Abbildung zeigt das Cockpit mit Beispieldaten.</a:t>
+              <a:t>So läuft eine IDD-Veranstaltung. Erstens: Freigeschaltete Anbietende setzen beim Anlegen den IDD-Haken, tragen den IDD-Titel ein und planen die Agenda. Je Eintrag legen sie Inhalte, Dauer und IDD-Bildungszeit fest. Die App prüft den Titel und die Summe. Zweitens: Teilnehmende sehen im Katalog Dauer und IDD-Zeit getrennt. Drittens: Nach der Session bestätigen die Anbietenden die Teilnahme innerhalb von 14 Tagen, danach die Administration. Viertens: Im IDD-Cockpit sehen Teilnehmende ihre Zeit je Kalenderjahr und laden den PDF-Nachweis. Die Abbildung zeigt das Cockpit mit Beispieldaten.</a:t>
             </a:r>
             <a:endParaRPr lang="en-US" dirty="0"/>
           </a:p>
@@ -14519,7 +14519,7 @@
                 <a:ea typeface="Arial" pitchFamily="34" charset="-122"/>
                 <a:cs typeface="Arial" pitchFamily="34" charset="-120"/>
               </a:rPr>
-              <a:t>IDD-Titel, IDD-Zeit und Agenda je Veranstaltung</a:t>
+              <a:t>IDD-Titel und Agenda mit IDD-Bildungszeit je Eintrag</a:t>
             </a:r>
             <a:endParaRPr lang="en-US" sz="1300" dirty="0"/>
           </a:p>
@@ -15389,7 +15389,7 @@
                 <a:ea typeface="Arial" pitchFamily="34" charset="-122"/>
                 <a:cs typeface="Arial" pitchFamily="34" charset="-120"/>
               </a:rPr>
-              <a:t>IDD-Titel, IDD-Zeit und automatische Agenda. Die App prüft den Titel.</a:t>
+              <a:t>IDD-Titel und Agenda mit Inhalten, Dauer und IDD-Bildungszeit. Die App prüft den Titel.</a:t>
             </a:r>
             <a:endParaRPr lang="en-US" sz="1250" dirty="0"/>
           </a:p>

</xml_diff>

<commit_message>
0.31.0: Beschreibung des Lerninhalts (IDD) und neue Formular-Reihenfolge
- Pflichtfeld mit den 11 gutBeraten-Kategorien, serverseitig geprueft
- Lerninhalt in Info-Kachel, ICS, Cockpit, IDD-Uebersicht, Archiv und PDF
- Formular: Worum > Angebot > Wann > IDD > Teilnahme und Teams-Link
- Handbuecher, Sicherheitspapier, Screenshots, Praesentation

Co-Authored-By: Claude Opus 5.5 <noreply@anthropic.com>
Claude-Session: https://claude.ai/code/session_01Rb6Lxu6RnQK1jTbYRZcruJ
</commit_message>
<xml_diff>
--- a/docs/LearnTogether-AD_Praesentation.pptx
+++ b/docs/LearnTogether-AD_Praesentation.pptx
@@ -978,7 +978,7 @@
           <a:p>
             <a:r>
               <a:rPr lang="en-US" dirty="0"/>
-              <a:t>Das Formular führt in vier Abschnitten: worum, wann, was und Teams-Link. Die Plattform prüft Zeitfenster und Dauer. Als Anbieter erscheint der Benutzername. Unter Meine Veranstaltungen lässt sich die Veranstaltung auch absagen. Angemeldete Personen sehen die Absage als Mitteilung, die Plattform verschickt keine E-Mails.</a:t>
+              <a:t>Das Formular folgt der Planung: worum es geht, was angeboten wird, wann es stattfindet, dann die IDD-Angaben und zum Schluss Teilnahme und Teams-Link. Die IDD-Agenda steht hinter der Dauer, weil sie die Dauer braucht. Die Plattform prüft Zeitfenster und Dauer. Als Anbieter erscheint der Benutzername. Unter Meine Veranstaltungen lässt sich die Veranstaltung auch absagen. Angemeldete Personen sehen die Absage als Mitteilung, die Plattform verschickt keine E-Mails.</a:t>
             </a:r>
             <a:endParaRPr lang="en-US" dirty="0"/>
           </a:p>
@@ -1946,7 +1946,7 @@
           <a:p>
             <a:r>
               <a:rPr lang="en-US" dirty="0"/>
-              <a:t>Die IDD-Anrechnung ist in der App umgesetzt und ab Werk ausgeschaltet. Freigeschaltete Anbietende legen IDD-Veranstaltungen mit IDD-Titel, IDD-Zeit und Agenda an. Nach der Session bestätigen sie, wer teilgenommen hat. Nur bestätigte Teilnahmen zählen. Teilnehmende sehen ihre Zeit je Kalenderjahr im IDD-Cockpit und laden einen PDF-Nachweis herunter. Am 31.01. des Folgejahres wird ein Jahr gesperrt. Offen sind das Format der Meldung an gutBeraten und die Freigaben. Der Pilot kann mit oder ohne IDD starten.</a:t>
+              <a:t>Die IDD-Anrechnung ist in der App umgesetzt und ab Werk ausgeschaltet. Freigeschaltete Anbietende legen IDD-Veranstaltungen mit IDD-Titel, Beschreibung des Lerninhalts, IDD-Zeit und Agenda an. Der Lerninhalt folgt den Kategorien von gutBeraten. Nach der Session bestätigen sie, wer teilgenommen hat. Nur bestätigte Teilnahmen zählen. Teilnehmende sehen ihre Zeit je Kalenderjahr im IDD-Cockpit und laden einen PDF-Nachweis herunter. Am 31.01. des Folgejahres wird ein Jahr gesperrt. Offen sind das Format der Meldung an gutBeraten und die Freigaben. Der Pilot kann mit oder ohne IDD starten.</a:t>
             </a:r>
             <a:endParaRPr lang="en-US" dirty="0"/>
           </a:p>
@@ -2034,7 +2034,7 @@
           <a:p>
             <a:r>
               <a:rPr lang="en-US" dirty="0"/>
-              <a:t>So läuft eine IDD-Veranstaltung. Erstens: Freigeschaltete Anbietende setzen beim Anlegen den IDD-Haken, tragen den IDD-Titel ein und planen die Agenda. Je Eintrag legen sie Inhalte, Dauer und IDD-Bildungszeit fest. Die App prüft den Titel und die Summe. Zweitens: Teilnehmende sehen im Katalog Dauer und IDD-Zeit getrennt. Drittens: Nach der Session bestätigen die Anbietenden die Teilnahme innerhalb von 14 Tagen, danach die Administration. Viertens: Im IDD-Cockpit sehen Teilnehmende ihre Zeit je Kalenderjahr und laden den PDF-Nachweis. Die Abbildung zeigt das Cockpit mit Beispieldaten.</a:t>
+              <a:t>So läuft eine IDD-Veranstaltung. Erstens: Freigeschaltete Anbietende setzen beim Anlegen den IDD-Haken, tragen den IDD-Titel ein, wählen die Beschreibung des Lerninhalts aus den Kategorien von gutBeraten und planen nach der Dauer die Agenda. Je Eintrag legen sie Inhalte, Dauer und IDD-Bildungszeit fest. Die App prüft den Titel und die Summe. Zweitens: Teilnehmende sehen im Katalog Dauer und IDD-Zeit getrennt. Drittens: Nach der Session bestätigen die Anbietenden die Teilnahme innerhalb von 14 Tagen, danach die Administration. Viertens: Im IDD-Cockpit sehen Teilnehmende ihre Zeit je Kalenderjahr und laden den PDF-Nachweis. Die Abbildung zeigt das Cockpit mit Beispieldaten.</a:t>
             </a:r>
             <a:endParaRPr lang="en-US" dirty="0"/>
           </a:p>
@@ -4881,7 +4881,7 @@
         <p:spPr>
           <a:xfrm>
             <a:off x="7680960" y="1508760"/>
-            <a:ext cx="4023360" cy="365760"/>
+            <a:ext cx="4023360" cy="329184"/>
           </a:xfrm>
           <a:prstGeom prst="rect">
             <a:avLst/>
@@ -4897,17 +4897,17 @@
               <a:buNone/>
             </a:pPr>
             <a:r>
-              <a:rPr lang="en-US" sz="1800" b="1" dirty="0">
-                <a:solidFill>
-                  <a:srgbClr val="001957"/>
-                </a:solidFill>
-                <a:latin typeface="Arial" pitchFamily="34" charset="0"/>
-                <a:ea typeface="Arial" pitchFamily="34" charset="-122"/>
-                <a:cs typeface="Arial" pitchFamily="34" charset="-120"/>
-              </a:rPr>
-              <a:t>Worum, wann</a:t>
-            </a:r>
-            <a:endParaRPr lang="en-US" sz="1800" dirty="0"/>
+              <a:rPr lang="en-US" sz="1600" b="1" dirty="0">
+                <a:solidFill>
+                  <a:srgbClr val="001957"/>
+                </a:solidFill>
+                <a:latin typeface="Arial" pitchFamily="34" charset="0"/>
+                <a:ea typeface="Arial" pitchFamily="34" charset="-122"/>
+                <a:cs typeface="Arial" pitchFamily="34" charset="-120"/>
+              </a:rPr>
+              <a:t>1 Worum geht es?</a:t>
+            </a:r>
+            <a:endParaRPr lang="en-US" sz="1600" dirty="0"/>
           </a:p>
         </p:txBody>
       </p:sp>
@@ -4919,8 +4919,8 @@
         </p:nvSpPr>
         <p:spPr>
           <a:xfrm>
-            <a:off x="7680960" y="1892808"/>
-            <a:ext cx="4023360" cy="640080"/>
+            <a:off x="7680960" y="1856232"/>
+            <a:ext cx="4023360" cy="502920"/>
           </a:xfrm>
           <a:prstGeom prst="rect">
             <a:avLst/>
@@ -4936,17 +4936,17 @@
               <a:buNone/>
             </a:pPr>
             <a:r>
-              <a:rPr lang="en-US" sz="1400" dirty="0">
-                <a:solidFill>
-                  <a:srgbClr val="001957"/>
-                </a:solidFill>
-                <a:latin typeface="Arial" pitchFamily="34" charset="0"/>
-                <a:ea typeface="Arial" pitchFamily="34" charset="-122"/>
-                <a:cs typeface="Arial" pitchFamily="34" charset="-120"/>
-              </a:rPr>
-              <a:t>Titel, Thema und ein Termin im erlaubten Zeitfenster.</a:t>
-            </a:r>
-            <a:endParaRPr lang="en-US" sz="1400" dirty="0"/>
+              <a:rPr lang="en-US" sz="1250" dirty="0">
+                <a:solidFill>
+                  <a:srgbClr val="001957"/>
+                </a:solidFill>
+                <a:latin typeface="Arial" pitchFamily="34" charset="0"/>
+                <a:ea typeface="Arial" pitchFamily="34" charset="-122"/>
+                <a:cs typeface="Arial" pitchFamily="34" charset="-120"/>
+              </a:rPr>
+              <a:t>Titel, Themenbereich, Thema und Art der Veranstaltung.</a:t>
+            </a:r>
+            <a:endParaRPr lang="en-US" sz="1250" dirty="0"/>
           </a:p>
         </p:txBody>
       </p:sp>
@@ -4958,8 +4958,8 @@
         </p:nvSpPr>
         <p:spPr>
           <a:xfrm>
-            <a:off x="7680960" y="2651760"/>
-            <a:ext cx="4023360" cy="365760"/>
+            <a:off x="7680960" y="2423160"/>
+            <a:ext cx="4023360" cy="329184"/>
           </a:xfrm>
           <a:prstGeom prst="rect">
             <a:avLst/>
@@ -4975,17 +4975,17 @@
               <a:buNone/>
             </a:pPr>
             <a:r>
-              <a:rPr lang="en-US" sz="1800" b="1" dirty="0">
-                <a:solidFill>
-                  <a:srgbClr val="001957"/>
-                </a:solidFill>
-                <a:latin typeface="Arial" pitchFamily="34" charset="0"/>
-                <a:ea typeface="Arial" pitchFamily="34" charset="-122"/>
-                <a:cs typeface="Arial" pitchFamily="34" charset="-120"/>
-              </a:rPr>
-              <a:t>Was wird angeboten</a:t>
-            </a:r>
-            <a:endParaRPr lang="en-US" sz="1800" dirty="0"/>
+              <a:rPr lang="en-US" sz="1600" b="1" dirty="0">
+                <a:solidFill>
+                  <a:srgbClr val="001957"/>
+                </a:solidFill>
+                <a:latin typeface="Arial" pitchFamily="34" charset="0"/>
+                <a:ea typeface="Arial" pitchFamily="34" charset="-122"/>
+                <a:cs typeface="Arial" pitchFamily="34" charset="-120"/>
+              </a:rPr>
+              <a:t>2 Was wird angeboten?</a:t>
+            </a:r>
+            <a:endParaRPr lang="en-US" sz="1600" dirty="0"/>
           </a:p>
         </p:txBody>
       </p:sp>
@@ -4997,8 +4997,8 @@
         </p:nvSpPr>
         <p:spPr>
           <a:xfrm>
-            <a:off x="7680960" y="3035808"/>
-            <a:ext cx="4023360" cy="640080"/>
+            <a:off x="7680960" y="2770632"/>
+            <a:ext cx="4023360" cy="502920"/>
           </a:xfrm>
           <a:prstGeom prst="rect">
             <a:avLst/>
@@ -5014,17 +5014,17 @@
               <a:buNone/>
             </a:pPr>
             <a:r>
-              <a:rPr lang="en-US" sz="1400" dirty="0">
-                <a:solidFill>
-                  <a:srgbClr val="001957"/>
-                </a:solidFill>
-                <a:latin typeface="Arial" pitchFamily="34" charset="0"/>
-                <a:ea typeface="Arial" pitchFamily="34" charset="-122"/>
-                <a:cs typeface="Arial" pitchFamily="34" charset="-120"/>
-              </a:rPr>
-              <a:t>Art, Platzzahl bis 50, Beschreibung und ein eigenes Bild oder ein Platzhalterbild.</a:t>
-            </a:r>
-            <a:endParaRPr lang="en-US" sz="1400" dirty="0"/>
+              <a:rPr lang="en-US" sz="1250" dirty="0">
+                <a:solidFill>
+                  <a:srgbClr val="001957"/>
+                </a:solidFill>
+                <a:latin typeface="Arial" pitchFamily="34" charset="0"/>
+                <a:ea typeface="Arial" pitchFamily="34" charset="-122"/>
+                <a:cs typeface="Arial" pitchFamily="34" charset="-120"/>
+              </a:rPr>
+              <a:t>Beschreibung und ein eigenes Bild oder ein Platzhalterbild.</a:t>
+            </a:r>
+            <a:endParaRPr lang="en-US" sz="1250" dirty="0"/>
           </a:p>
         </p:txBody>
       </p:sp>
@@ -5036,8 +5036,8 @@
         </p:nvSpPr>
         <p:spPr>
           <a:xfrm>
-            <a:off x="7680960" y="3794760"/>
-            <a:ext cx="4023360" cy="365760"/>
+            <a:off x="7680960" y="3337560"/>
+            <a:ext cx="4023360" cy="329184"/>
           </a:xfrm>
           <a:prstGeom prst="rect">
             <a:avLst/>
@@ -5053,17 +5053,17 @@
               <a:buNone/>
             </a:pPr>
             <a:r>
-              <a:rPr lang="en-US" sz="1800" b="1" dirty="0">
-                <a:solidFill>
-                  <a:srgbClr val="001957"/>
-                </a:solidFill>
-                <a:latin typeface="Arial" pitchFamily="34" charset="0"/>
-                <a:ea typeface="Arial" pitchFamily="34" charset="-122"/>
-                <a:cs typeface="Arial" pitchFamily="34" charset="-120"/>
-              </a:rPr>
-              <a:t>Teams-Link</a:t>
-            </a:r>
-            <a:endParaRPr lang="en-US" sz="1800" dirty="0"/>
+              <a:rPr lang="en-US" sz="1600" b="1" dirty="0">
+                <a:solidFill>
+                  <a:srgbClr val="001957"/>
+                </a:solidFill>
+                <a:latin typeface="Arial" pitchFamily="34" charset="0"/>
+                <a:ea typeface="Arial" pitchFamily="34" charset="-122"/>
+                <a:cs typeface="Arial" pitchFamily="34" charset="-120"/>
+              </a:rPr>
+              <a:t>3 Wann findet es statt?</a:t>
+            </a:r>
+            <a:endParaRPr lang="en-US" sz="1600" dirty="0"/>
           </a:p>
         </p:txBody>
       </p:sp>
@@ -5075,8 +5075,8 @@
         </p:nvSpPr>
         <p:spPr>
           <a:xfrm>
-            <a:off x="7680960" y="4178808"/>
-            <a:ext cx="4023360" cy="640080"/>
+            <a:off x="7680960" y="3685032"/>
+            <a:ext cx="4023360" cy="502920"/>
           </a:xfrm>
           <a:prstGeom prst="rect">
             <a:avLst/>
@@ -5092,17 +5092,17 @@
               <a:buNone/>
             </a:pPr>
             <a:r>
-              <a:rPr lang="en-US" sz="1400" dirty="0">
-                <a:solidFill>
-                  <a:srgbClr val="001957"/>
-                </a:solidFill>
-                <a:latin typeface="Arial" pitchFamily="34" charset="0"/>
-                <a:ea typeface="Arial" pitchFamily="34" charset="-122"/>
-                <a:cs typeface="Arial" pitchFamily="34" charset="-120"/>
-              </a:rPr>
-              <a:t>Der Link ist nur für angemeldete Personen sichtbar.</a:t>
-            </a:r>
-            <a:endParaRPr lang="en-US" sz="1400" dirty="0"/>
+              <a:rPr lang="en-US" sz="1250" dirty="0">
+                <a:solidFill>
+                  <a:srgbClr val="001957"/>
+                </a:solidFill>
+                <a:latin typeface="Arial" pitchFamily="34" charset="0"/>
+                <a:ea typeface="Arial" pitchFamily="34" charset="-122"/>
+                <a:cs typeface="Arial" pitchFamily="34" charset="-120"/>
+              </a:rPr>
+              <a:t>Tag, Dauer und Startzeit im erlaubten Zeitfenster.</a:t>
+            </a:r>
+            <a:endParaRPr lang="en-US" sz="1250" dirty="0"/>
           </a:p>
         </p:txBody>
       </p:sp>
@@ -5114,8 +5114,8 @@
         </p:nvSpPr>
         <p:spPr>
           <a:xfrm>
-            <a:off x="7680960" y="4937760"/>
-            <a:ext cx="4023360" cy="365760"/>
+            <a:off x="7680960" y="4251960"/>
+            <a:ext cx="4023360" cy="329184"/>
           </a:xfrm>
           <a:prstGeom prst="rect">
             <a:avLst/>
@@ -5131,17 +5131,17 @@
               <a:buNone/>
             </a:pPr>
             <a:r>
-              <a:rPr lang="en-US" sz="1800" b="1" dirty="0">
-                <a:solidFill>
-                  <a:srgbClr val="001957"/>
-                </a:solidFill>
-                <a:latin typeface="Arial" pitchFamily="34" charset="0"/>
-                <a:ea typeface="Arial" pitchFamily="34" charset="-122"/>
-                <a:cs typeface="Arial" pitchFamily="34" charset="-120"/>
-              </a:rPr>
-              <a:t>Meine Veranstaltungen</a:t>
-            </a:r>
-            <a:endParaRPr lang="en-US" sz="1800" dirty="0"/>
+              <a:rPr lang="en-US" sz="1600" b="1" dirty="0">
+                <a:solidFill>
+                  <a:srgbClr val="001957"/>
+                </a:solidFill>
+                <a:latin typeface="Arial" pitchFamily="34" charset="0"/>
+                <a:ea typeface="Arial" pitchFamily="34" charset="-122"/>
+                <a:cs typeface="Arial" pitchFamily="34" charset="-120"/>
+              </a:rPr>
+              <a:t>4 IDD-Weiterbildung</a:t>
+            </a:r>
+            <a:endParaRPr lang="en-US" sz="1600" dirty="0"/>
           </a:p>
         </p:txBody>
       </p:sp>
@@ -5153,8 +5153,8 @@
         </p:nvSpPr>
         <p:spPr>
           <a:xfrm>
-            <a:off x="7680960" y="5321808"/>
-            <a:ext cx="4023360" cy="640080"/>
+            <a:off x="7680960" y="4599432"/>
+            <a:ext cx="4023360" cy="502920"/>
           </a:xfrm>
           <a:prstGeom prst="rect">
             <a:avLst/>
@@ -5170,23 +5170,101 @@
               <a:buNone/>
             </a:pPr>
             <a:r>
-              <a:rPr lang="en-US" sz="1400" dirty="0">
-                <a:solidFill>
-                  <a:srgbClr val="001957"/>
-                </a:solidFill>
-                <a:latin typeface="Arial" pitchFamily="34" charset="0"/>
-                <a:ea typeface="Arial" pitchFamily="34" charset="-122"/>
-                <a:cs typeface="Arial" pitchFamily="34" charset="-120"/>
-              </a:rPr>
-              <a:t>Teilnehmende mit Benutzernamen, Bewertung, Bearbeiten und Absage.</a:t>
-            </a:r>
-            <a:endParaRPr lang="en-US" sz="1400" dirty="0"/>
+              <a:rPr lang="en-US" sz="1250" dirty="0">
+                <a:solidFill>
+                  <a:srgbClr val="001957"/>
+                </a:solidFill>
+                <a:latin typeface="Arial" pitchFamily="34" charset="0"/>
+                <a:ea typeface="Arial" pitchFamily="34" charset="-122"/>
+                <a:cs typeface="Arial" pitchFamily="34" charset="-120"/>
+              </a:rPr>
+              <a:t>Mit Freischaltung: IDD-Titel, Lerninhalt und Agenda zur Dauer.</a:t>
+            </a:r>
+            <a:endParaRPr lang="en-US" sz="1250" dirty="0"/>
           </a:p>
         </p:txBody>
       </p:sp>
       <p:sp>
         <p:nvSpPr>
           <p:cNvPr id="17" name="Text 12"/>
+          <p:cNvSpPr txBox="1"/>
+          <p:nvPr/>
+        </p:nvSpPr>
+        <p:spPr>
+          <a:xfrm>
+            <a:off x="7680960" y="5166360"/>
+            <a:ext cx="4023360" cy="329184"/>
+          </a:xfrm>
+          <a:prstGeom prst="rect">
+            <a:avLst/>
+          </a:prstGeom>
+          <a:noFill/>
+          <a:ln/>
+        </p:spPr>
+        <p:txBody>
+          <a:bodyPr wrap="square" lIns="0" tIns="0" rIns="0" bIns="0" rtlCol="0" anchor="t"/>
+          <a:lstStyle/>
+          <a:p>
+            <a:pPr indent="0" marL="0">
+              <a:buNone/>
+            </a:pPr>
+            <a:r>
+              <a:rPr lang="en-US" sz="1600" b="1" dirty="0">
+                <a:solidFill>
+                  <a:srgbClr val="001957"/>
+                </a:solidFill>
+                <a:latin typeface="Arial" pitchFamily="34" charset="0"/>
+                <a:ea typeface="Arial" pitchFamily="34" charset="-122"/>
+                <a:cs typeface="Arial" pitchFamily="34" charset="-120"/>
+              </a:rPr>
+              <a:t>5 Teilnahme und Teams-Link</a:t>
+            </a:r>
+            <a:endParaRPr lang="en-US" sz="1600" dirty="0"/>
+          </a:p>
+        </p:txBody>
+      </p:sp>
+      <p:sp>
+        <p:nvSpPr>
+          <p:cNvPr id="18" name="Text 13"/>
+          <p:cNvSpPr txBox="1"/>
+          <p:nvPr/>
+        </p:nvSpPr>
+        <p:spPr>
+          <a:xfrm>
+            <a:off x="7680960" y="5513832"/>
+            <a:ext cx="4023360" cy="502920"/>
+          </a:xfrm>
+          <a:prstGeom prst="rect">
+            <a:avLst/>
+          </a:prstGeom>
+          <a:noFill/>
+          <a:ln/>
+        </p:spPr>
+        <p:txBody>
+          <a:bodyPr wrap="square" lIns="0" tIns="0" rIns="0" bIns="0" rtlCol="0" anchor="t"/>
+          <a:lstStyle/>
+          <a:p>
+            <a:pPr indent="0" marL="0">
+              <a:buNone/>
+            </a:pPr>
+            <a:r>
+              <a:rPr lang="en-US" sz="1250" dirty="0">
+                <a:solidFill>
+                  <a:srgbClr val="001957"/>
+                </a:solidFill>
+                <a:latin typeface="Arial" pitchFamily="34" charset="0"/>
+                <a:ea typeface="Arial" pitchFamily="34" charset="-122"/>
+                <a:cs typeface="Arial" pitchFamily="34" charset="-120"/>
+              </a:rPr>
+              <a:t>Platzzahl bis 50. Der Link ist nur für Angemeldete sichtbar.</a:t>
+            </a:r>
+            <a:endParaRPr lang="en-US" sz="1250" dirty="0"/>
+          </a:p>
+        </p:txBody>
+      </p:sp>
+      <p:sp>
+        <p:nvSpPr>
+          <p:cNvPr id="19" name="Text 14"/>
           <p:cNvSpPr txBox="1"/>
           <p:nvPr/>
         </p:nvSpPr>
@@ -14519,7 +14597,7 @@
                 <a:ea typeface="Arial" pitchFamily="34" charset="-122"/>
                 <a:cs typeface="Arial" pitchFamily="34" charset="-120"/>
               </a:rPr>
-              <a:t>IDD-Titel und Agenda mit IDD-Bildungszeit je Eintrag</a:t>
+              <a:t>IDD-Titel, Lerninhalt nach gutBeraten-Kategorie, Agenda</a:t>
             </a:r>
             <a:endParaRPr lang="en-US" sz="1300" dirty="0"/>
           </a:p>
@@ -15389,7 +15467,7 @@
                 <a:ea typeface="Arial" pitchFamily="34" charset="-122"/>
                 <a:cs typeface="Arial" pitchFamily="34" charset="-120"/>
               </a:rPr>
-              <a:t>IDD-Titel und Agenda mit Inhalten, Dauer und IDD-Bildungszeit. Die App prüft den Titel.</a:t>
+              <a:t>IDD-Titel, Lerninhalt nach gutBeraten und Agenda mit IDD-Bildungszeit. Die App prüft den Titel.</a:t>
             </a:r>
             <a:endParaRPr lang="en-US" sz="1250" dirty="0"/>
           </a:p>

</xml_diff>

<commit_message>
0.31.1: "Wann findet es statt?" vor "Was wird angeboten?"
Co-Authored-By: Claude Opus 5.5 <noreply@anthropic.com>
Claude-Session: https://claude.ai/code/session_01Rb6Lxu6RnQK1jTbYRZcruJ
</commit_message>
<xml_diff>
--- a/docs/LearnTogether-AD_Praesentation.pptx
+++ b/docs/LearnTogether-AD_Praesentation.pptx
@@ -978,7 +978,7 @@
           <a:p>
             <a:r>
               <a:rPr lang="en-US" dirty="0"/>
-              <a:t>Das Formular folgt der Planung: worum es geht, was angeboten wird, wann es stattfindet, dann die IDD-Angaben und zum Schluss Teilnahme und Teams-Link. Die IDD-Agenda steht hinter der Dauer, weil sie die Dauer braucht. Die Plattform prüft Zeitfenster und Dauer. Als Anbieter erscheint der Benutzername. Unter Meine Veranstaltungen lässt sich die Veranstaltung auch absagen. Angemeldete Personen sehen die Absage als Mitteilung, die Plattform verschickt keine E-Mails.</a:t>
+              <a:t>Das Formular folgt der Planung: worum es geht, wann es stattfindet, was angeboten wird, dann die IDD-Angaben und zum Schluss Teilnahme und Teams-Link. Die IDD-Agenda steht hinter der Dauer, weil sie die Dauer braucht. Die Plattform prüft Zeitfenster und Dauer. Als Anbieter erscheint der Benutzername. Unter Meine Veranstaltungen lässt sich die Veranstaltung auch absagen. Angemeldete Personen sehen die Absage als Mitteilung, die Plattform verschickt keine E-Mails.</a:t>
             </a:r>
             <a:endParaRPr lang="en-US" dirty="0"/>
           </a:p>
@@ -4983,7 +4983,7 @@
                 <a:ea typeface="Arial" pitchFamily="34" charset="-122"/>
                 <a:cs typeface="Arial" pitchFamily="34" charset="-120"/>
               </a:rPr>
-              <a:t>2 Was wird angeboten?</a:t>
+              <a:t>2 Wann findet es statt?</a:t>
             </a:r>
             <a:endParaRPr lang="en-US" sz="1600" dirty="0"/>
           </a:p>
@@ -5022,7 +5022,7 @@
                 <a:ea typeface="Arial" pitchFamily="34" charset="-122"/>
                 <a:cs typeface="Arial" pitchFamily="34" charset="-120"/>
               </a:rPr>
-              <a:t>Beschreibung und ein eigenes Bild oder ein Platzhalterbild.</a:t>
+              <a:t>Tag, Dauer und Startzeit im erlaubten Zeitfenster.</a:t>
             </a:r>
             <a:endParaRPr lang="en-US" sz="1250" dirty="0"/>
           </a:p>
@@ -5061,7 +5061,7 @@
                 <a:ea typeface="Arial" pitchFamily="34" charset="-122"/>
                 <a:cs typeface="Arial" pitchFamily="34" charset="-120"/>
               </a:rPr>
-              <a:t>3 Wann findet es statt?</a:t>
+              <a:t>3 Was wird angeboten?</a:t>
             </a:r>
             <a:endParaRPr lang="en-US" sz="1600" dirty="0"/>
           </a:p>
@@ -5100,7 +5100,7 @@
                 <a:ea typeface="Arial" pitchFamily="34" charset="-122"/>
                 <a:cs typeface="Arial" pitchFamily="34" charset="-120"/>
               </a:rPr>
-              <a:t>Tag, Dauer und Startzeit im erlaubten Zeitfenster.</a:t>
+              <a:t>Beschreibung und ein eigenes Bild oder ein Platzhalterbild.</a:t>
             </a:r>
             <a:endParaRPr lang="en-US" sz="1250" dirty="0"/>
           </a:p>

</xml_diff>

<commit_message>
Praesentation: IDD-Anrechnung geplant, im Ausbau, Freischaltung folgt
Co-Authored-By: Claude Opus 5.5 <noreply@anthropic.com>
Claude-Session: https://claude.ai/code/session_01Rb6Lxu6RnQK1jTbYRZcruJ
</commit_message>
<xml_diff>
--- a/docs/LearnTogether-AD_Praesentation.pptx
+++ b/docs/LearnTogether-AD_Praesentation.pptx
@@ -1770,7 +1770,7 @@
           <a:p>
             <a:r>
               <a:rPr lang="en-US" dirty="0"/>
-              <a:t>Die Idee in einem Satz: Kolleginnen und Kollegen teilen ihr Wissen in kurzen Online-Terminen, alle anderen lernen mit. Ich zeige gleich ehrlich, was heute schon funktioniert und was noch in Planung ist. Besonders wichtig: Die IDD-Anrechnung ist in der App umgesetzt, aber ab Werk ausgeschaltet. Die Meldung an gutBeraten folgt. Für dienstliche Sessions gilt die Arbeitszeitregel: Wer teilnimmt, stempelt sich selbst ein. Am Ende bitte ich um die Freigabe für einen Pilot.</a:t>
+              <a:t>Die Idee in einem Satz: Kolleginnen und Kollegen teilen ihr Wissen in kurzen Online-Terminen, alle anderen lernen mit. Ich zeige gleich ehrlich, was heute schon funktioniert und was noch in Planung ist. Besonders wichtig: Die Anrechnung von IDD-Zeiten ist für anrechnungsfähige Veranstaltungen aus dem beruflichen Bereich geplant. Sie wird aktuell ausgebaut und soll zukünftig freigeschaltet werden. Die Meldung an gutBeraten folgt. Für dienstliche Sessions gilt die Arbeitszeitregel: Wer teilnimmt, stempelt sich selbst ein. Am Ende bitte ich um die Freigabe für einen Pilot.</a:t>
             </a:r>
             <a:endParaRPr lang="en-US" dirty="0"/>
           </a:p>
@@ -1946,7 +1946,7 @@
           <a:p>
             <a:r>
               <a:rPr lang="en-US" dirty="0"/>
-              <a:t>Die IDD-Anrechnung ist in der App umgesetzt und ab Werk ausgeschaltet. Freigeschaltete Anbietende legen IDD-Veranstaltungen mit IDD-Titel, Beschreibung des Lerninhalts, IDD-Zeit und Agenda an. Der Lerninhalt folgt den Kategorien von gutBeraten. Nach der Session bestätigen sie, wer teilgenommen hat. Nur bestätigte Teilnahmen zählen. Teilnehmende sehen ihre Zeit je Kalenderjahr im IDD-Cockpit und laden einen PDF-Nachweis herunter. Am 31.01. des Folgejahres wird ein Jahr gesperrt. Offen sind das Format der Meldung an gutBeraten und die Freigaben. Der Pilot kann mit oder ohne IDD starten.</a:t>
+              <a:t>Die Anrechnung von IDD-Zeiten ist für anrechnungsfähige Veranstaltungen aus dem beruflichen Bereich geplant. Wir bauen sie aktuell in der App aus. Zukünftig soll sie freigeschaltet werden. Bis dahin ist die Funktion ausgeschaltet. Freigeschaltete Anbietende legen IDD-Veranstaltungen mit IDD-Titel, Beschreibung des Lerninhalts, IDD-Zeit und Agenda an. Der Lerninhalt folgt den Kategorien von gutBeraten. Nach der Session bestätigen sie, wer teilgenommen hat. Nur bestätigte Teilnahmen zählen. Teilnehmende sehen ihre Zeit je Kalenderjahr im IDD-Cockpit und laden einen PDF-Nachweis herunter. Am 31.01. des Folgejahres wird ein Jahr gesperrt. Offen sind das Format der Meldung an gutBeraten und die Freigaben. Der Pilot kann ohne IDD starten, die Anrechnung kommt später dazu.</a:t>
             </a:r>
             <a:endParaRPr lang="en-US" dirty="0"/>
           </a:p>
@@ -2034,7 +2034,7 @@
           <a:p>
             <a:r>
               <a:rPr lang="en-US" dirty="0"/>
-              <a:t>So läuft eine IDD-Veranstaltung. Erstens: Freigeschaltete Anbietende setzen beim Anlegen den IDD-Haken, tragen den IDD-Titel ein, wählen die Beschreibung des Lerninhalts aus den Kategorien von gutBeraten und planen nach der Dauer die Agenda. Je Eintrag legen sie Inhalte, Dauer und IDD-Bildungszeit fest. Die App prüft den Titel und die Summe. Zweitens: Teilnehmende sehen im Katalog Dauer und IDD-Zeit getrennt. Drittens: Nach der Session bestätigen die Anbietenden die Teilnahme innerhalb von 14 Tagen, danach die Administration. Viertens: Im IDD-Cockpit sehen Teilnehmende ihre Zeit je Kalenderjahr und laden den PDF-Nachweis. Die Abbildung zeigt das Cockpit mit Beispieldaten.</a:t>
+              <a:t>So soll eine IDD-Veranstaltung nach der Freischaltung laufen. Der Ablauf gilt nur für anrechnungsfähige berufliche Veranstaltungen. Erstens: Freigeschaltete Anbietende setzen beim Anlegen den IDD-Haken, tragen den IDD-Titel ein, wählen die Beschreibung des Lerninhalts aus den Kategorien von gutBeraten und planen nach der Dauer die Agenda. Je Eintrag legen sie Inhalte, Dauer und IDD-Bildungszeit fest. Die App prüft den Titel und die Summe. Zweitens: Teilnehmende sehen im Katalog Dauer und IDD-Zeit getrennt. Drittens: Nach der Session bestätigen die Anbietenden die Teilnahme innerhalb von 14 Tagen, danach die Administration. Viertens: Im IDD-Cockpit sehen Teilnehmende ihre Zeit je Kalenderjahr und laden den PDF-Nachweis. Die Abbildung zeigt das Cockpit mit Beispieldaten.</a:t>
             </a:r>
             <a:endParaRPr lang="en-US" dirty="0"/>
           </a:p>
@@ -2474,7 +2474,7 @@
           <a:p>
             <a:r>
               <a:rPr lang="en-US" dirty="0"/>
-              <a:t>Das ist ein Vorschlag, die Zeiträume stimmen wir gemeinsam ab. Phase 1 ist der Pilot im Außendienst. In Phase 2 schalten wir die IDD-Funktion frei, setzen die Meldung an gutBeraten um und werten den Pilot aus. In Phase 3 gehen die IDD-Termine in den Regelbetrieb.</a:t>
+              <a:t>Das ist ein Vorschlag, die Zeiträume stimmen wir gemeinsam ab. Phase 1 ist der Pilot im Außendienst. In Phase 2 schalten wir die IDD-Anrechnung für berufliche Veranstaltungen frei, setzen die Meldung an gutBeraten um und werten den Pilot aus. In Phase 3 gehen die IDD-Termine in den Regelbetrieb.</a:t>
             </a:r>
             <a:endParaRPr lang="en-US" dirty="0"/>
           </a:p>
@@ -2562,7 +2562,7 @@
           <a:p>
             <a:r>
               <a:rPr lang="en-US" dirty="0"/>
-              <a:t>Zum Schluss die konkrete Bitte, vier Entscheidungen. Wir starten klein, lernen schnell und binden alle Beteiligten ein. Die IDD-Funktion ist umgesetzt. Für ihren Start brauchen wir die Freigaben und die Meldung an gutBeraten.</a:t>
+              <a:t>Zum Schluss die konkrete Bitte, vier Entscheidungen. Wir starten klein, lernen schnell und binden alle Beteiligten ein. Die IDD-Anrechnung für berufliche Veranstaltungen ist geplant und wird ausgebaut. Für ihre Freischaltung brauchen wir die Freigaben und die Meldung an gutBeraten.</a:t>
             </a:r>
             <a:endParaRPr lang="en-US" dirty="0"/>
           </a:p>
@@ -2914,7 +2914,7 @@
           <a:p>
             <a:r>
               <a:rPr lang="en-US" dirty="0"/>
-              <a:t>Die Beispiele zeigen: Es braucht wenig Technik und viel Vertrauen. Wir übernehmen das Prinzip, Kolleginnen und Kollegen bieten an. Anders sind unsere festen Zeitfenster, die Trennung in dienstlich und privat und die IDD-Anrechnung mit bestätigter Teilnahme.</a:t>
+              <a:t>Die Beispiele zeigen: Es braucht wenig Technik und viel Vertrauen. Wir übernehmen das Prinzip, Kolleginnen und Kollegen bieten an. Anders sind unsere festen Zeitfenster, die Trennung in dienstlich und privat und die geplante IDD-Anrechnung mit bestätigter Teilnahme.</a:t>
             </a:r>
             <a:endParaRPr lang="en-US" dirty="0"/>
           </a:p>
@@ -12528,7 +12528,7 @@
                 <a:ea typeface="Arial" pitchFamily="34" charset="-122"/>
                 <a:cs typeface="Arial" pitchFamily="34" charset="-120"/>
               </a:rPr>
-              <a:t>IDD: umgesetzt, Start nach Freigabe</a:t>
+              <a:t>IDD-Anrechnung beruflicher Termine: im Ausbau</a:t>
             </a:r>
             <a:endParaRPr lang="en-US" sz="1250" dirty="0"/>
           </a:p>
@@ -12591,7 +12591,7 @@
                 <a:ea typeface="Arial" pitchFamily="34" charset="-122"/>
                 <a:cs typeface="Arial" pitchFamily="34" charset="-120"/>
               </a:rPr>
-              <a:t>Meldung der Zeiten an gutBeraten</a:t>
+              <a:t>Freischaltung der IDD-Anrechnung, Meldung an gutBeraten</a:t>
             </a:r>
             <a:endParaRPr lang="en-US" sz="1250" dirty="0"/>
           </a:p>
@@ -14230,7 +14230,7 @@
                 <a:ea typeface="Arial" pitchFamily="34" charset="-122"/>
                 <a:cs typeface="Arial" pitchFamily="34" charset="-120"/>
               </a:rPr>
-              <a:t>IDD-Anrechnung: in der App umgesetzt</a:t>
+              <a:t>IDD-Anrechnung: geplant und im Ausbau</a:t>
             </a:r>
             <a:endParaRPr lang="en-US" sz="2800" dirty="0"/>
           </a:p>
@@ -14269,7 +14269,7 @@
                 <a:ea typeface="Arial" pitchFamily="34" charset="-122"/>
                 <a:cs typeface="Arial" pitchFamily="34" charset="-120"/>
               </a:rPr>
-              <a:t>Start nach Freigabe, die Meldung an gutBeraten folgt</a:t>
+              <a:t>Für anrechnungsfähige Veranstaltungen aus dem beruflichen Bereich</a:t>
             </a:r>
             <a:endParaRPr lang="en-US" sz="2000" dirty="0"/>
           </a:p>
@@ -14466,7 +14466,7 @@
                 <a:ea typeface="Arial" pitchFamily="34" charset="-122"/>
                 <a:cs typeface="Arial" pitchFamily="34" charset="-120"/>
               </a:rPr>
-              <a:t>Umgesetzt. Start nach Freigabe.</a:t>
+              <a:t>Geplant. Im Ausbau. Freischaltung folgt.</a:t>
             </a:r>
             <a:endParaRPr lang="en-US" sz="1600" dirty="0"/>
           </a:p>
@@ -14554,7 +14554,7 @@
                 <a:ea typeface="Arial" pitchFamily="34" charset="-122"/>
                 <a:cs typeface="Arial" pitchFamily="34" charset="-120"/>
               </a:rPr>
-              <a:t>In der App</a:t>
+              <a:t>Im Ausbau</a:t>
             </a:r>
             <a:endParaRPr lang="en-US" sz="1800" dirty="0"/>
           </a:p>
@@ -15048,7 +15048,7 @@
                 <a:ea typeface="Arial" pitchFamily="34" charset="-122"/>
                 <a:cs typeface="Arial" pitchFamily="34" charset="-120"/>
               </a:rPr>
-              <a:t>IDD-Funktion einschalten</a:t>
+              <a:t>Freischaltung der IDD-Anrechnung</a:t>
             </a:r>
             <a:endParaRPr lang="en-US" sz="1300" dirty="0"/>
           </a:p>
@@ -15158,7 +15158,7 @@
                 <a:ea typeface="Arial" pitchFamily="34" charset="-122"/>
                 <a:cs typeface="Arial" pitchFamily="34" charset="-120"/>
               </a:rPr>
-              <a:t>Vier Schritte, alles in LearnTogether@AD</a:t>
+              <a:t>So soll es nach der Freischaltung laufen</a:t>
             </a:r>
             <a:endParaRPr lang="en-US" sz="2000" dirty="0"/>
           </a:p>
@@ -15926,7 +15926,7 @@
                 <a:ea typeface="Arial" pitchFamily="34" charset="-122"/>
                 <a:cs typeface="Arial" pitchFamily="34" charset="-120"/>
               </a:rPr>
-              <a:t>Die Bestätigung dient nur der IDD-Anrechnung. Ab Werk ist die Funktion aus. Nachträge brauchen eine Begründung und stehen im Protokoll.</a:t>
+              <a:t>Die Bestätigung dient nur der IDD-Anrechnung. Bis zur Freischaltung ist die Funktion aus. Nachträge brauchen eine Begründung und stehen im Protokoll.</a:t>
             </a:r>
             <a:endParaRPr lang="en-US" sz="1300" dirty="0"/>
           </a:p>
@@ -20134,7 +20134,7 @@
                 <a:ea typeface="Arial" pitchFamily="34" charset="-122"/>
                 <a:cs typeface="Arial" pitchFamily="34" charset="-120"/>
               </a:rPr>
-              <a:t>IDD starten</a:t>
+              <a:t>IDD freischalten</a:t>
             </a:r>
             <a:endParaRPr lang="en-US" sz="2000" dirty="0"/>
           </a:p>
@@ -20202,7 +20202,7 @@
                 <a:ea typeface="Arial" pitchFamily="34" charset="-122"/>
                 <a:cs typeface="Arial" pitchFamily="34" charset="-120"/>
               </a:rPr>
-              <a:t>IDD-Funktion freigeben</a:t>
+              <a:t>IDD-Anrechnung freischalten</a:t>
             </a:r>
             <a:endParaRPr lang="en-US" sz="1500" dirty="0"/>
           </a:p>
@@ -21109,7 +21109,7 @@
                 <a:ea typeface="Arial" pitchFamily="34" charset="-122"/>
                 <a:cs typeface="Arial" pitchFamily="34" charset="-120"/>
               </a:rPr>
-              <a:t>Compliance und Datenschutz prüfen die Umsetzung. Danach Meldung an gutBeraten umsetzen und einschalten.</a:t>
+              <a:t>Geplant und im Ausbau. Compliance und Datenschutz prüfen. Danach Meldung an gutBeraten umsetzen und freischalten.</a:t>
             </a:r>
             <a:endParaRPr lang="en-US" sz="1400" dirty="0"/>
           </a:p>
@@ -24454,7 +24454,7 @@
                           <a:ea typeface="Arial" pitchFamily="34" charset="-122"/>
                           <a:cs typeface="Arial" pitchFamily="34" charset="-120"/>
                         </a:rPr>
-                        <a:t>Feste Zeitfenster, dienstlich und privat, Bewertungen und Abzeichen, IDD-Anrechnung</a:t>
+                        <a:t>Feste Zeitfenster, dienstlich und privat, Bewertungen und Abzeichen, geplante IDD-Anrechnung</a:t>
                       </a:r>
                       <a:endParaRPr lang="en-US" sz="1200" dirty="0">
                         <a:latin typeface="Arial" charset="0"/>

</xml_diff>

<commit_message>
0.33.0: LearnMaker statt Anbietende
Co-Authored-By: Claude Opus 5.5 <noreply@anthropic.com>
Claude-Session: https://claude.ai/code/session_01Rb6Lxu6RnQK1jTbYRZcruJ
</commit_message>
<xml_diff>
--- a/docs/LearnTogether-AD_Praesentation.pptx
+++ b/docs/LearnTogether-AD_Praesentation.pptx
@@ -978,7 +978,7 @@
           <a:p>
             <a:r>
               <a:rPr lang="en-US" dirty="0"/>
-              <a:t>Das Formular folgt der Planung: worum es geht, wann es stattfindet, was angeboten wird, dann die IDD-Angaben und zum Schluss Teilnahme und Teams-Link. Die IDD-Agenda steht hinter der Dauer, weil sie die Dauer braucht. Die Plattform prüft Zeitfenster und Dauer. Als Anbieter erscheint der Benutzername. Unter Meine Veranstaltungen lässt sich die Veranstaltung auch absagen. Angemeldete Personen sehen die Absage als Mitteilung, die Plattform verschickt keine E-Mails.</a:t>
+              <a:t>Das Formular folgt der Planung: worum es geht, wann es stattfindet, was angeboten wird, dann die IDD-Angaben und zum Schluss Teilnahme und Teams-Link. Die IDD-Agenda steht hinter der Dauer, weil sie die Dauer braucht. Die Plattform prüft Zeitfenster und Dauer. Wer anbietet, ist LearnMaker. Als LearnMaker erscheint der Benutzername. Unter Meine Veranstaltungen lässt sich die Veranstaltung auch absagen. Angemeldete Personen sehen die Absage als Mitteilung, die Plattform verschickt keine E-Mails.</a:t>
             </a:r>
             <a:endParaRPr lang="en-US" dirty="0"/>
           </a:p>
@@ -1154,7 +1154,7 @@
           <a:p>
             <a:r>
               <a:rPr lang="en-US" dirty="0"/>
-              <a:t>Jede Person sieht ihre Anmeldungen und ihre eigenen Veranstaltungen an einem Ort. Ein Schalter trennt Anstehend und Vergangen. Anbietende sehen die Teilnehmenden nur mit Benutzernamen und können selbst absagen. Wer angemeldet ist, erhält dann eine Mitteilung in der App. Nach dem Termin vergeben Teilnehmende ein bis fünf Sterne.</a:t>
+              <a:t>Jede Person sieht ihre Anmeldungen und ihre eigenen Veranstaltungen an einem Ort. Ein Schalter trennt Anstehend und Vergangen. LearnMaker sehen die Teilnehmenden nur mit Benutzernamen und können selbst absagen. Wer angemeldet ist, erhält dann eine Mitteilung in der App. Nach dem Termin vergeben Teilnehmende ein bis fünf Sterne.</a:t>
             </a:r>
             <a:endParaRPr lang="en-US" dirty="0"/>
           </a:p>
@@ -1858,7 +1858,7 @@
           <a:p>
             <a:r>
               <a:rPr lang="en-US" dirty="0"/>
-              <a:t>Die Zielwerte leiten sich aus der Zielgruppe von rund 6.000 Personen ab. Wir rechnen mit zwei Monaten Anlauf. Rund 40 Anbietende, also etwa jede 150. Person, bieten im Schnitt zwei bis drei Sessions an. Das ergibt rund 100 Sessions, etwa vier pro Woche. Bei durchschnittlich zehn Teilnehmenden kommen rund 1.000 Teilnahmen zusammen. Bei Ø 45 Minuten sind das rund 750 Lernstunden. Nimmt jede Person im Schnitt gut zweimal teil, erreichen wir etwa 450 Personen, also 7,5 Prozent der Zielgruppe. Mindestens 35 Prozent sollen wiederkommen. Das zeigt, dass das Angebot trägt. Alle Werte liefert die Statistik direkt.</a:t>
+              <a:t>Die Zielwerte leiten sich aus der Zielgruppe von rund 6.000 Personen ab. Wir rechnen mit zwei Monaten Anlauf. Rund 40 LearnMaker, also etwa jede 150. Person, bieten im Schnitt zwei bis drei Sessions an. Das ergibt rund 100 Sessions, etwa vier pro Woche. Bei durchschnittlich zehn Teilnehmenden kommen rund 1.000 Teilnahmen zusammen. Bei Ø 45 Minuten sind das rund 750 Lernstunden. Nimmt jede Person im Schnitt gut zweimal teil, erreichen wir etwa 450 Personen, also 7,5 Prozent der Zielgruppe. Mindestens 35 Prozent sollen wiederkommen. Das zeigt, dass das Angebot trägt. Alle Werte liefert die Statistik direkt.</a:t>
             </a:r>
             <a:endParaRPr lang="en-US" dirty="0"/>
           </a:p>
@@ -1946,7 +1946,7 @@
           <a:p>
             <a:r>
               <a:rPr lang="en-US" dirty="0"/>
-              <a:t>Die Anrechnung von IDD-Zeiten ist für anrechnungsfähige Veranstaltungen aus dem beruflichen Bereich geplant. Wir bauen sie aktuell in der App aus. Zukünftig soll sie freigeschaltet werden. Bis dahin ist die Funktion ausgeschaltet. Freigeschaltete Anbietende legen IDD-Veranstaltungen mit IDD-Titel, Beschreibung des Lerninhalts, IDD-Zeit und Agenda an. Der Lerninhalt folgt den Kategorien von gutBeraten. Nach der Session bestätigen sie, wer teilgenommen hat. Nur bestätigte Teilnahmen zählen. Teilnehmende sehen ihre Zeit je Kalenderjahr im IDD-Cockpit und laden einen PDF-Nachweis herunter. Am 31.01. des Folgejahres wird ein Jahr gesperrt. Offen sind das Format der Meldung an gutBeraten und die Freigaben. Der Pilot kann ohne IDD starten, die Anrechnung kommt später dazu.</a:t>
+              <a:t>Die Anrechnung von IDD-Zeiten ist für anrechnungsfähige Veranstaltungen aus dem beruflichen Bereich geplant. Wir bauen sie aktuell in der App aus. Zukünftig soll sie freigeschaltet werden. Bis dahin ist die Funktion ausgeschaltet. Freigeschaltete LearnMaker legen IDD-Veranstaltungen mit IDD-Titel, Beschreibung des Lerninhalts, IDD-Zeit und Agenda an. Der Lerninhalt folgt den Kategorien von gutBeraten. Nach der Session bestätigen sie, wer teilgenommen hat. Nur bestätigte Teilnahmen zählen. Teilnehmende sehen ihre Zeit je Kalenderjahr im IDD-Cockpit und laden einen PDF-Nachweis herunter. Am 31.01. des Folgejahres wird ein Jahr gesperrt. Offen sind das Format der Meldung an gutBeraten und die Freigaben. Der Pilot kann ohne IDD starten, die Anrechnung kommt später dazu.</a:t>
             </a:r>
             <a:endParaRPr lang="en-US" dirty="0"/>
           </a:p>
@@ -2034,7 +2034,7 @@
           <a:p>
             <a:r>
               <a:rPr lang="en-US" dirty="0"/>
-              <a:t>So soll eine IDD-Veranstaltung nach der Freischaltung laufen. Der Ablauf gilt nur für anrechnungsfähige berufliche Veranstaltungen. Erstens: Freigeschaltete Anbietende setzen beim Anlegen den IDD-Haken, tragen den IDD-Titel ein, wählen die Beschreibung des Lerninhalts aus den Kategorien von gutBeraten und planen nach der Dauer die Agenda. Je Eintrag legen sie Inhalte, Dauer und IDD-Bildungszeit fest. Die App prüft den Titel und die Summe. Zweitens: Teilnehmende sehen im Katalog Dauer und IDD-Zeit getrennt. Drittens: Nach der Session bestätigen die Anbietenden die Teilnahme innerhalb von 14 Tagen, danach die Administration. Viertens: Im IDD-Cockpit sehen Teilnehmende ihre Zeit je Kalenderjahr und laden den PDF-Nachweis. Die Abbildung zeigt das Cockpit mit Beispieldaten.</a:t>
+              <a:t>So soll eine IDD-Veranstaltung nach der Freischaltung laufen. Der Ablauf gilt nur für anrechnungsfähige berufliche Veranstaltungen. Erstens: Freigeschaltete LearnMaker setzen beim Anlegen den IDD-Haken, tragen den IDD-Titel ein, wählen die Beschreibung des Lerninhalts aus den Kategorien von gutBeraten und planen nach der Dauer die Agenda. Je Eintrag legen sie Inhalte, Dauer und IDD-Bildungszeit fest. Die App prüft den Titel und die Summe. Zweitens: Teilnehmende sehen im Katalog Dauer und IDD-Zeit getrennt. Drittens: Nach der Session bestätigen die LearnMaker die Teilnahme innerhalb von 14 Tagen, danach die Administration. Viertens: Im IDD-Cockpit sehen Teilnehmende ihre Zeit je Kalenderjahr und laden den PDF-Nachweis. Die Abbildung zeigt das Cockpit mit Beispieldaten.</a:t>
             </a:r>
             <a:endParaRPr lang="en-US" dirty="0"/>
           </a:p>
@@ -4684,7 +4684,7 @@
                 <a:ea typeface="Arial" pitchFamily="34" charset="-122"/>
                 <a:cs typeface="Arial" pitchFamily="34" charset="-120"/>
               </a:rPr>
-              <a:t>Selbst etwas anbieten</a:t>
+              <a:t>Werde LearnMaker: selbst etwas anbieten</a:t>
             </a:r>
             <a:endParaRPr lang="en-US" sz="2800" dirty="0"/>
           </a:p>
@@ -8055,7 +8055,7 @@
                 <a:ea typeface="Arial" pitchFamily="34" charset="-122"/>
                 <a:cs typeface="Arial" pitchFamily="34" charset="-120"/>
               </a:rPr>
-              <a:t>Die Platzzahl legt die anbietende Person fest. Ausgebuchte Termine sind gesperrt.</a:t>
+              <a:t>Die Platzzahl legt der LearnMaker fest. Ausgebuchte Termine sind gesperrt.</a:t>
             </a:r>
             <a:endParaRPr lang="en-US" sz="1200" dirty="0"/>
           </a:p>
@@ -9892,7 +9892,7 @@
                 <a:ea typeface="Arial" pitchFamily="34" charset="-122"/>
                 <a:cs typeface="Arial" pitchFamily="34" charset="-120"/>
               </a:rPr>
-              <a:t>Anbietende</a:t>
+              <a:t>LearnMaker</a:t>
             </a:r>
             <a:endParaRPr lang="en-US" sz="2200" dirty="0"/>
           </a:p>
@@ -11328,7 +11328,7 @@
                 <a:ea typeface="Arial" pitchFamily="34" charset="-122"/>
                 <a:cs typeface="Arial" pitchFamily="34" charset="-120"/>
               </a:rPr>
-              <a:t>Termine pro Monat, Themen, Arten, Anbietende</a:t>
+              <a:t>Termine pro Monat, Themen, Arten, LearnMaker</a:t>
             </a:r>
             <a:endParaRPr lang="en-US" sz="1400" dirty="0"/>
           </a:p>
@@ -13490,7 +13490,7 @@
                 <a:ea typeface="Arial" pitchFamily="34" charset="-122"/>
                 <a:cs typeface="Arial" pitchFamily="34" charset="-120"/>
               </a:rPr>
-              <a:t>Anbietende</a:t>
+              <a:t>LearnMaker</a:t>
             </a:r>
             <a:endParaRPr lang="en-US" sz="1400" dirty="0"/>
           </a:p>
@@ -13944,7 +13944,7 @@
                 <a:ea typeface="Arial" pitchFamily="34" charset="-122"/>
                 <a:cs typeface="Arial" pitchFamily="34" charset="-120"/>
               </a:rPr>
-              <a:t>Zwischenstand nach 3 Monaten: 200 Personen, 25 Anbietende</a:t>
+              <a:t>Zwischenstand nach 3 Monaten: 200 Personen, 25 LearnMaker</a:t>
             </a:r>
             <a:endParaRPr lang="en-US" sz="1400" dirty="0"/>
           </a:p>
@@ -14639,7 +14639,7 @@
                 <a:ea typeface="Arial" pitchFamily="34" charset="-122"/>
                 <a:cs typeface="Arial" pitchFamily="34" charset="-120"/>
               </a:rPr>
-              <a:t>Teilnahme bestätigen: 14 Tage Anbietende, danach Administration</a:t>
+              <a:t>Teilnahme bestätigen: 14 Tage LearnMaker, danach Administration</a:t>
             </a:r>
             <a:endParaRPr lang="en-US" sz="1300" dirty="0"/>
           </a:p>
@@ -15721,7 +15721,7 @@
                 <a:ea typeface="Arial" pitchFamily="34" charset="-122"/>
                 <a:cs typeface="Arial" pitchFamily="34" charset="-120"/>
               </a:rPr>
-              <a:t>Anbietende 14 Tage, danach die Administration. Sperre am 31.01.</a:t>
+              <a:t>LearnMaker 14 Tage, danach die Administration. Sperre am 31.01.</a:t>
             </a:r>
             <a:endParaRPr lang="en-US" sz="1250" dirty="0"/>
           </a:p>
@@ -16328,7 +16328,7 @@
                 <a:ea typeface="Arial" pitchFamily="34" charset="-122"/>
                 <a:cs typeface="Arial" pitchFamily="34" charset="-120"/>
               </a:rPr>
-              <a:t>Anbietende sehen Teilnehmende nur mit Benutzernamen.</a:t>
+              <a:t>LearnMaker sehen Teilnehmende nur mit Benutzernamen.</a:t>
             </a:r>
             <a:endParaRPr lang="en-US" sz="1400" dirty="0"/>
           </a:p>
@@ -18993,7 +18993,7 @@
                           <a:ea typeface="Arial" pitchFamily="34" charset="-122"/>
                           <a:cs typeface="Arial" pitchFamily="34" charset="-120"/>
                         </a:rPr>
-                        <a:t>Führungskräfte und Fachleute bieten die ersten Termine an. Die Administration spricht gezielt Anbietende an.</a:t>
+                        <a:t>Führungskräfte und Fachleute bieten die ersten Termine an. Die Administration spricht gezielt LearnMaker an.</a:t>
                       </a:r>
                       <a:endParaRPr lang="en-US" sz="1300" dirty="0">
                         <a:latin typeface="Arial" charset="0"/>
@@ -19389,7 +19389,7 @@
                           <a:ea typeface="Arial" pitchFamily="34" charset="-122"/>
                           <a:cs typeface="Arial" pitchFamily="34" charset="-120"/>
                         </a:rPr>
-                        <a:t>Klare Spielregeln, Bewertungen mit Sternen, Abzeichen für aktive Anbietende, Termine lassen sich bearbeiten oder entfernen.</a:t>
+                        <a:t>Klare Spielregeln, Bewertungen mit Sternen, Abzeichen für aktive LearnMaker, Termine lassen sich bearbeiten oder entfernen.</a:t>
                       </a:r>
                       <a:endParaRPr lang="en-US" sz="1300" dirty="0">
                         <a:latin typeface="Arial" charset="0"/>
@@ -20031,7 +20031,7 @@
                 <a:ea typeface="Arial" pitchFamily="34" charset="-122"/>
                 <a:cs typeface="Arial" pitchFamily="34" charset="-120"/>
               </a:rPr>
-              <a:t>Erste Anbietende gewinnen, auch Führungskräfte</a:t>
+              <a:t>Erste LearnMaker gewinnen, auch Führungskräfte</a:t>
             </a:r>
             <a:endParaRPr lang="en-US" sz="1500" dirty="0"/>
           </a:p>
@@ -20457,7 +20457,7 @@
                 <a:ea typeface="Arial" pitchFamily="34" charset="-122"/>
                 <a:cs typeface="Arial" pitchFamily="34" charset="-120"/>
               </a:rPr>
-              <a:t>Mehr Anbietende und Themen</a:t>
+              <a:t>Mehr LearnMaker und Themen</a:t>
             </a:r>
             <a:endParaRPr lang="en-US" sz="1500" dirty="0"/>
           </a:p>
@@ -25573,7 +25573,7 @@
                 <a:ea typeface="Arial" pitchFamily="34" charset="-122"/>
                 <a:cs typeface="Arial" pitchFamily="34" charset="-120"/>
               </a:rPr>
-              <a:t>Bei uns: Wiederkehrende Termine und Anbietende, die sich kennenlernen.</a:t>
+              <a:t>Bei uns: Wiederkehrende Termine und LearnMaker, die sich kennenlernen.</a:t>
             </a:r>
             <a:endParaRPr lang="en-US" sz="1300" dirty="0"/>
           </a:p>

</xml_diff>